<commit_message>
Rubens Teil in Präsentation aktualisiert
Co-Authored-By: Claude Sonnet 4.6 <noreply@anthropic.com>
</commit_message>
<xml_diff>
--- a/Elevator_Control_Presentation_v4.pptx
+++ b/Elevator_Control_Presentation_v4.pptx
@@ -2341,7 +2341,7 @@
         </p:nvSpPr>
         <p:spPr>
           <a:xfrm>
-            <a:off x="640080" y="1783080"/>
+            <a:off x="640080" y="2971800"/>
             <a:ext cx="10972800" cy="1005840"/>
           </a:xfrm>
           <a:prstGeom prst="rect">
@@ -2369,62 +2369,6 @@
               <a:t>Elevator Control System</a:t>
             </a:r>
             <a:endParaRPr lang="en-US" sz="5000" dirty="0"/>
-          </a:p>
-        </p:txBody>
-      </p:sp>
-      <p:sp>
-        <p:nvSpPr>
-          <p:cNvPr id="6" name="Text 3"/>
-          <p:cNvSpPr/>
-          <p:nvPr/>
-        </p:nvSpPr>
-        <p:spPr>
-          <a:xfrm>
-            <a:off x="640080" y="2834640"/>
-            <a:ext cx="10241280" cy="822960"/>
-          </a:xfrm>
-          <a:prstGeom prst="rect">
-            <a:avLst/>
-          </a:prstGeom>
-          <a:noFill/>
-          <a:ln/>
-        </p:spPr>
-        <p:txBody>
-          <a:bodyPr wrap="square" lIns="0" tIns="0" rIns="0" bIns="0" rtlCol="0" anchor="ctr"/>
-          <a:lstStyle/>
-          <a:p>
-            <a:pPr marL="0" indent="0">
-              <a:buNone/>
-            </a:pPr>
-            <a:r>
-              <a:rPr lang="en-US" sz="1800" dirty="0">
-                <a:solidFill>
-                  <a:srgbClr val="333331"/>
-                </a:solidFill>
-                <a:latin typeface="Arial" pitchFamily="34" charset="0"/>
-                <a:ea typeface="Arial" pitchFamily="34" charset="-122"/>
-                <a:cs typeface="Arial" pitchFamily="34" charset="-120"/>
-              </a:rPr>
-              <a:t>A collective-control elevator for a 4-level PLC simulation:</a:t>
-            </a:r>
-            <a:endParaRPr lang="en-US" sz="1800" dirty="0"/>
-          </a:p>
-          <a:p>
-            <a:pPr marL="0" indent="0">
-              <a:buNone/>
-            </a:pPr>
-            <a:r>
-              <a:rPr lang="en-US" sz="1800" dirty="0">
-                <a:solidFill>
-                  <a:srgbClr val="333331"/>
-                </a:solidFill>
-                <a:latin typeface="Arial" pitchFamily="34" charset="0"/>
-                <a:ea typeface="Arial" pitchFamily="34" charset="-122"/>
-                <a:cs typeface="Arial" pitchFamily="34" charset="-120"/>
-              </a:rPr>
-              <a:t>the control logic and its MQTT operator interface (HMI).</a:t>
-            </a:r>
-            <a:endParaRPr lang="en-US" sz="1800" dirty="0"/>
           </a:p>
         </p:txBody>
       </p:sp>
@@ -2460,325 +2404,13 @@
       </p:sp>
       <p:sp>
         <p:nvSpPr>
-          <p:cNvPr id="8" name="Text 5"/>
-          <p:cNvSpPr/>
-          <p:nvPr/>
-        </p:nvSpPr>
-        <p:spPr>
-          <a:xfrm>
-            <a:off x="640080" y="4206240"/>
-            <a:ext cx="5120640" cy="320040"/>
-          </a:xfrm>
-          <a:prstGeom prst="rect">
-            <a:avLst/>
-          </a:prstGeom>
-          <a:noFill/>
-          <a:ln/>
-        </p:spPr>
-        <p:txBody>
-          <a:bodyPr wrap="square" lIns="0" tIns="0" rIns="0" bIns="0" rtlCol="0" anchor="ctr"/>
-          <a:lstStyle/>
-          <a:p>
-            <a:pPr marL="0" indent="0">
-              <a:buNone/>
-            </a:pPr>
-            <a:r>
-              <a:rPr lang="en-US" sz="1300" b="1" kern="0" spc="200" dirty="0">
-                <a:solidFill>
-                  <a:srgbClr val="0B6E7A"/>
-                </a:solidFill>
-                <a:latin typeface="Arial" pitchFamily="34" charset="0"/>
-                <a:ea typeface="Arial" pitchFamily="34" charset="-122"/>
-                <a:cs typeface="Arial" pitchFamily="34" charset="-120"/>
-              </a:rPr>
-              <a:t>HMI TEAM</a:t>
-            </a:r>
-            <a:endParaRPr lang="en-US" sz="1300" dirty="0"/>
-          </a:p>
-        </p:txBody>
-      </p:sp>
-      <p:sp>
-        <p:nvSpPr>
-          <p:cNvPr id="9" name="Text 6"/>
-          <p:cNvSpPr/>
-          <p:nvPr/>
-        </p:nvSpPr>
-        <p:spPr>
-          <a:xfrm>
-            <a:off x="640080" y="4498848"/>
-            <a:ext cx="5120640" cy="274320"/>
-          </a:xfrm>
-          <a:prstGeom prst="rect">
-            <a:avLst/>
-          </a:prstGeom>
-          <a:noFill/>
-          <a:ln/>
-        </p:spPr>
-        <p:txBody>
-          <a:bodyPr wrap="square" lIns="0" tIns="0" rIns="0" bIns="0" rtlCol="0" anchor="ctr"/>
-          <a:lstStyle/>
-          <a:p>
-            <a:pPr marL="0" indent="0">
-              <a:buNone/>
-            </a:pPr>
-            <a:r>
-              <a:rPr lang="en-US" sz="1200" i="1" dirty="0">
-                <a:solidFill>
-                  <a:srgbClr val="6E6E6C"/>
-                </a:solidFill>
-                <a:latin typeface="Arial" pitchFamily="34" charset="0"/>
-                <a:ea typeface="Arial" pitchFamily="34" charset="-122"/>
-                <a:cs typeface="Arial" pitchFamily="34" charset="-120"/>
-              </a:rPr>
-              <a:t>operator interface</a:t>
-            </a:r>
-            <a:endParaRPr lang="en-US" sz="1200" dirty="0"/>
-          </a:p>
-        </p:txBody>
-      </p:sp>
-      <p:sp>
-        <p:nvSpPr>
-          <p:cNvPr id="10" name="Text 7"/>
-          <p:cNvSpPr/>
-          <p:nvPr/>
-        </p:nvSpPr>
-        <p:spPr>
-          <a:xfrm>
-            <a:off x="640080" y="4937760"/>
-            <a:ext cx="2286000" cy="411480"/>
-          </a:xfrm>
-          <a:prstGeom prst="rect">
-            <a:avLst/>
-          </a:prstGeom>
-          <a:noFill/>
-          <a:ln/>
-        </p:spPr>
-        <p:txBody>
-          <a:bodyPr wrap="square" lIns="0" tIns="0" rIns="0" bIns="0" rtlCol="0" anchor="ctr"/>
-          <a:lstStyle/>
-          <a:p>
-            <a:pPr marL="0" indent="0">
-              <a:buNone/>
-            </a:pPr>
-            <a:r>
-              <a:rPr lang="en-US" sz="1900" b="1" dirty="0">
-                <a:solidFill>
-                  <a:srgbClr val="2D2D2B"/>
-                </a:solidFill>
-                <a:latin typeface="Arial" pitchFamily="34" charset="0"/>
-                <a:ea typeface="Arial" pitchFamily="34" charset="-122"/>
-                <a:cs typeface="Arial" pitchFamily="34" charset="-120"/>
-              </a:rPr>
-              <a:t>Yasin</a:t>
-            </a:r>
-            <a:endParaRPr lang="en-US" sz="1900" dirty="0"/>
-          </a:p>
-        </p:txBody>
-      </p:sp>
-      <p:sp>
-        <p:nvSpPr>
-          <p:cNvPr id="11" name="Text 8"/>
-          <p:cNvSpPr/>
-          <p:nvPr/>
-        </p:nvSpPr>
-        <p:spPr>
-          <a:xfrm>
-            <a:off x="3108960" y="4937760"/>
-            <a:ext cx="2286000" cy="411480"/>
-          </a:xfrm>
-          <a:prstGeom prst="rect">
-            <a:avLst/>
-          </a:prstGeom>
-          <a:noFill/>
-          <a:ln/>
-        </p:spPr>
-        <p:txBody>
-          <a:bodyPr wrap="square" lIns="0" tIns="0" rIns="0" bIns="0" rtlCol="0" anchor="ctr"/>
-          <a:lstStyle/>
-          <a:p>
-            <a:pPr marL="0" indent="0">
-              <a:buNone/>
-            </a:pPr>
-            <a:r>
-              <a:rPr lang="en-US" sz="1900" b="1" dirty="0">
-                <a:solidFill>
-                  <a:srgbClr val="2D2D2B"/>
-                </a:solidFill>
-                <a:latin typeface="Arial" pitchFamily="34" charset="0"/>
-                <a:ea typeface="Arial" pitchFamily="34" charset="-122"/>
-                <a:cs typeface="Arial" pitchFamily="34" charset="-120"/>
-              </a:rPr>
-              <a:t>Mevlüt</a:t>
-            </a:r>
-            <a:endParaRPr lang="en-US" sz="1900" dirty="0"/>
-          </a:p>
-        </p:txBody>
-      </p:sp>
-      <p:sp>
-        <p:nvSpPr>
-          <p:cNvPr id="12" name="Text 9"/>
-          <p:cNvSpPr/>
-          <p:nvPr/>
-        </p:nvSpPr>
-        <p:spPr>
-          <a:xfrm>
-            <a:off x="6126480" y="4206240"/>
-            <a:ext cx="5120640" cy="320040"/>
-          </a:xfrm>
-          <a:prstGeom prst="rect">
-            <a:avLst/>
-          </a:prstGeom>
-          <a:noFill/>
-          <a:ln/>
-        </p:spPr>
-        <p:txBody>
-          <a:bodyPr wrap="square" lIns="0" tIns="0" rIns="0" bIns="0" rtlCol="0" anchor="ctr"/>
-          <a:lstStyle/>
-          <a:p>
-            <a:pPr marL="0" indent="0">
-              <a:buNone/>
-            </a:pPr>
-            <a:r>
-              <a:rPr lang="en-US" sz="1300" b="1" kern="0" spc="200" dirty="0">
-                <a:solidFill>
-                  <a:srgbClr val="0B6E7A"/>
-                </a:solidFill>
-                <a:latin typeface="Arial" pitchFamily="34" charset="0"/>
-                <a:ea typeface="Arial" pitchFamily="34" charset="-122"/>
-                <a:cs typeface="Arial" pitchFamily="34" charset="-120"/>
-              </a:rPr>
-              <a:t>CONTROL TEAM</a:t>
-            </a:r>
-            <a:endParaRPr lang="en-US" sz="1300" dirty="0"/>
-          </a:p>
-        </p:txBody>
-      </p:sp>
-      <p:sp>
-        <p:nvSpPr>
-          <p:cNvPr id="13" name="Text 10"/>
-          <p:cNvSpPr/>
-          <p:nvPr/>
-        </p:nvSpPr>
-        <p:spPr>
-          <a:xfrm>
-            <a:off x="6126480" y="4498848"/>
-            <a:ext cx="5120640" cy="274320"/>
-          </a:xfrm>
-          <a:prstGeom prst="rect">
-            <a:avLst/>
-          </a:prstGeom>
-          <a:noFill/>
-          <a:ln/>
-        </p:spPr>
-        <p:txBody>
-          <a:bodyPr wrap="square" lIns="0" tIns="0" rIns="0" bIns="0" rtlCol="0" anchor="ctr"/>
-          <a:lstStyle/>
-          <a:p>
-            <a:pPr marL="0" indent="0">
-              <a:buNone/>
-            </a:pPr>
-            <a:r>
-              <a:rPr lang="en-US" sz="1200" i="1" dirty="0">
-                <a:solidFill>
-                  <a:srgbClr val="6E6E6C"/>
-                </a:solidFill>
-                <a:latin typeface="Arial" pitchFamily="34" charset="0"/>
-                <a:ea typeface="Arial" pitchFamily="34" charset="-122"/>
-                <a:cs typeface="Arial" pitchFamily="34" charset="-120"/>
-              </a:rPr>
-              <a:t>the control system</a:t>
-            </a:r>
-            <a:endParaRPr lang="en-US" sz="1200" dirty="0"/>
-          </a:p>
-        </p:txBody>
-      </p:sp>
-      <p:sp>
-        <p:nvSpPr>
-          <p:cNvPr id="14" name="Text 11"/>
-          <p:cNvSpPr/>
-          <p:nvPr/>
-        </p:nvSpPr>
-        <p:spPr>
-          <a:xfrm>
-            <a:off x="6126480" y="4937760"/>
-            <a:ext cx="2286000" cy="411480"/>
-          </a:xfrm>
-          <a:prstGeom prst="rect">
-            <a:avLst/>
-          </a:prstGeom>
-          <a:noFill/>
-          <a:ln/>
-        </p:spPr>
-        <p:txBody>
-          <a:bodyPr wrap="square" lIns="0" tIns="0" rIns="0" bIns="0" rtlCol="0" anchor="ctr"/>
-          <a:lstStyle/>
-          <a:p>
-            <a:pPr marL="0" indent="0">
-              <a:buNone/>
-            </a:pPr>
-            <a:r>
-              <a:rPr lang="en-US" sz="1900" b="1" dirty="0">
-                <a:solidFill>
-                  <a:srgbClr val="2D2D2B"/>
-                </a:solidFill>
-                <a:latin typeface="Arial" pitchFamily="34" charset="0"/>
-                <a:ea typeface="Arial" pitchFamily="34" charset="-122"/>
-                <a:cs typeface="Arial" pitchFamily="34" charset="-120"/>
-              </a:rPr>
-              <a:t>Ruben</a:t>
-            </a:r>
-            <a:endParaRPr lang="en-US" sz="1900" dirty="0"/>
-          </a:p>
-        </p:txBody>
-      </p:sp>
-      <p:sp>
-        <p:nvSpPr>
-          <p:cNvPr id="15" name="Text 12"/>
-          <p:cNvSpPr/>
-          <p:nvPr/>
-        </p:nvSpPr>
-        <p:spPr>
-          <a:xfrm>
-            <a:off x="8595360" y="4937760"/>
-            <a:ext cx="2286000" cy="411480"/>
-          </a:xfrm>
-          <a:prstGeom prst="rect">
-            <a:avLst/>
-          </a:prstGeom>
-          <a:noFill/>
-          <a:ln/>
-        </p:spPr>
-        <p:txBody>
-          <a:bodyPr wrap="square" lIns="0" tIns="0" rIns="0" bIns="0" rtlCol="0" anchor="ctr"/>
-          <a:lstStyle/>
-          <a:p>
-            <a:pPr marL="0" indent="0">
-              <a:buNone/>
-            </a:pPr>
-            <a:r>
-              <a:rPr lang="en-US" sz="1900" b="1" dirty="0">
-                <a:solidFill>
-                  <a:srgbClr val="2D2D2B"/>
-                </a:solidFill>
-                <a:latin typeface="Arial" pitchFamily="34" charset="0"/>
-                <a:ea typeface="Arial" pitchFamily="34" charset="-122"/>
-                <a:cs typeface="Arial" pitchFamily="34" charset="-120"/>
-              </a:rPr>
-              <a:t>Lukas</a:t>
-            </a:r>
-            <a:endParaRPr lang="en-US" sz="1900" dirty="0"/>
-          </a:p>
-        </p:txBody>
-      </p:sp>
-      <p:sp>
-        <p:nvSpPr>
           <p:cNvPr id="16" name="Text 13"/>
           <p:cNvSpPr/>
           <p:nvPr/>
         </p:nvSpPr>
         <p:spPr>
           <a:xfrm>
-            <a:off x="640080" y="6172200"/>
+            <a:off x="640080" y="4075981"/>
             <a:ext cx="5486400" cy="320040"/>
           </a:xfrm>
           <a:prstGeom prst="rect">
@@ -2889,7 +2521,7 @@
         </p:nvSpPr>
         <p:spPr>
           <a:xfrm>
-            <a:off x="640080" y="804672"/>
+            <a:off x="621792" y="689864"/>
             <a:ext cx="10515600" cy="731520"/>
           </a:xfrm>
           <a:prstGeom prst="rect">
@@ -2952,45 +2584,6 @@
       </p:sp>
       <p:sp>
         <p:nvSpPr>
-          <p:cNvPr id="6" name="Text 4"/>
-          <p:cNvSpPr/>
-          <p:nvPr/>
-        </p:nvSpPr>
-        <p:spPr>
-          <a:xfrm>
-            <a:off x="640080" y="6437376"/>
-            <a:ext cx="8229600" cy="274320"/>
-          </a:xfrm>
-          <a:prstGeom prst="rect">
-            <a:avLst/>
-          </a:prstGeom>
-          <a:noFill/>
-          <a:ln/>
-        </p:spPr>
-        <p:txBody>
-          <a:bodyPr wrap="square" lIns="0" tIns="0" rIns="0" bIns="0" rtlCol="0" anchor="ctr"/>
-          <a:lstStyle/>
-          <a:p>
-            <a:pPr marL="0" indent="0">
-              <a:buNone/>
-            </a:pPr>
-            <a:r>
-              <a:rPr lang="en-US" sz="900" dirty="0">
-                <a:solidFill>
-                  <a:srgbClr val="6E6E6C"/>
-                </a:solidFill>
-                <a:latin typeface="Arial" pitchFamily="34" charset="0"/>
-                <a:ea typeface="Arial" pitchFamily="34" charset="-122"/>
-                <a:cs typeface="Arial" pitchFamily="34" charset="-120"/>
-              </a:rPr>
-              <a:t>HTWG Konstanz  ·  System Architecture  ·  Group E</a:t>
-            </a:r>
-            <a:endParaRPr lang="en-US" sz="900" dirty="0"/>
-          </a:p>
-        </p:txBody>
-      </p:sp>
-      <p:sp>
-        <p:nvSpPr>
           <p:cNvPr id="7" name="Text 5"/>
           <p:cNvSpPr/>
           <p:nvPr/>
@@ -3036,7 +2629,7 @@
         </p:nvSpPr>
         <p:spPr>
           <a:xfrm>
-            <a:off x="640080" y="1737360"/>
+            <a:off x="640080" y="1536192"/>
             <a:ext cx="5349240" cy="658368"/>
           </a:xfrm>
           <a:prstGeom prst="rect">
@@ -3068,7 +2661,7 @@
         </p:nvSpPr>
         <p:spPr>
           <a:xfrm>
-            <a:off x="749808" y="1737360"/>
+            <a:off x="749808" y="1536192"/>
             <a:ext cx="548640" cy="658368"/>
           </a:xfrm>
           <a:prstGeom prst="rect">
@@ -3107,7 +2700,7 @@
         </p:nvSpPr>
         <p:spPr>
           <a:xfrm>
-            <a:off x="1353312" y="1737360"/>
+            <a:off x="1353312" y="1536192"/>
             <a:ext cx="4526280" cy="658368"/>
           </a:xfrm>
           <a:prstGeom prst="rect">
@@ -3146,7 +2739,7 @@
         </p:nvSpPr>
         <p:spPr>
           <a:xfrm>
-            <a:off x="6199632" y="1737360"/>
+            <a:off x="6199632" y="1536192"/>
             <a:ext cx="5349240" cy="658368"/>
           </a:xfrm>
           <a:prstGeom prst="rect">
@@ -3178,7 +2771,7 @@
         </p:nvSpPr>
         <p:spPr>
           <a:xfrm>
-            <a:off x="6309360" y="1737360"/>
+            <a:off x="6309360" y="1536192"/>
             <a:ext cx="548640" cy="658368"/>
           </a:xfrm>
           <a:prstGeom prst="rect">
@@ -3217,7 +2810,7 @@
         </p:nvSpPr>
         <p:spPr>
           <a:xfrm>
-            <a:off x="6912864" y="1737360"/>
+            <a:off x="6912864" y="1536192"/>
             <a:ext cx="4526280" cy="658368"/>
           </a:xfrm>
           <a:prstGeom prst="rect">
@@ -3256,7 +2849,7 @@
         </p:nvSpPr>
         <p:spPr>
           <a:xfrm>
-            <a:off x="640080" y="2505456"/>
+            <a:off x="640080" y="2304288"/>
             <a:ext cx="5349240" cy="658368"/>
           </a:xfrm>
           <a:prstGeom prst="rect">
@@ -3288,7 +2881,7 @@
         </p:nvSpPr>
         <p:spPr>
           <a:xfrm>
-            <a:off x="749808" y="2505456"/>
+            <a:off x="749808" y="2304288"/>
             <a:ext cx="548640" cy="658368"/>
           </a:xfrm>
           <a:prstGeom prst="rect">
@@ -3327,7 +2920,7 @@
         </p:nvSpPr>
         <p:spPr>
           <a:xfrm>
-            <a:off x="1353312" y="2505456"/>
+            <a:off x="1353312" y="2304288"/>
             <a:ext cx="4526280" cy="658368"/>
           </a:xfrm>
           <a:prstGeom prst="rect">
@@ -3366,7 +2959,7 @@
         </p:nvSpPr>
         <p:spPr>
           <a:xfrm>
-            <a:off x="6199632" y="2505456"/>
+            <a:off x="6199632" y="2304288"/>
             <a:ext cx="5349240" cy="658368"/>
           </a:xfrm>
           <a:prstGeom prst="rect">
@@ -3398,7 +2991,7 @@
         </p:nvSpPr>
         <p:spPr>
           <a:xfrm>
-            <a:off x="6309360" y="2505456"/>
+            <a:off x="6309360" y="2304288"/>
             <a:ext cx="548640" cy="658368"/>
           </a:xfrm>
           <a:prstGeom prst="rect">
@@ -3437,7 +3030,7 @@
         </p:nvSpPr>
         <p:spPr>
           <a:xfrm>
-            <a:off x="6912864" y="2505456"/>
+            <a:off x="6912864" y="2304288"/>
             <a:ext cx="4526280" cy="658368"/>
           </a:xfrm>
           <a:prstGeom prst="rect">
@@ -3476,7 +3069,7 @@
         </p:nvSpPr>
         <p:spPr>
           <a:xfrm>
-            <a:off x="640080" y="3273552"/>
+            <a:off x="640080" y="3072384"/>
             <a:ext cx="5349240" cy="658368"/>
           </a:xfrm>
           <a:prstGeom prst="rect">
@@ -3508,7 +3101,7 @@
         </p:nvSpPr>
         <p:spPr>
           <a:xfrm>
-            <a:off x="749808" y="3273552"/>
+            <a:off x="749808" y="3072384"/>
             <a:ext cx="548640" cy="658368"/>
           </a:xfrm>
           <a:prstGeom prst="rect">
@@ -3547,7 +3140,7 @@
         </p:nvSpPr>
         <p:spPr>
           <a:xfrm>
-            <a:off x="1353312" y="3273552"/>
+            <a:off x="1353312" y="3072384"/>
             <a:ext cx="4526280" cy="658368"/>
           </a:xfrm>
           <a:prstGeom prst="rect">
@@ -3586,7 +3179,7 @@
         </p:nvSpPr>
         <p:spPr>
           <a:xfrm>
-            <a:off x="6199632" y="3273552"/>
+            <a:off x="6199632" y="3072384"/>
             <a:ext cx="5349240" cy="658368"/>
           </a:xfrm>
           <a:prstGeom prst="rect">
@@ -3618,7 +3211,7 @@
         </p:nvSpPr>
         <p:spPr>
           <a:xfrm>
-            <a:off x="6309360" y="3273552"/>
+            <a:off x="6309360" y="3072384"/>
             <a:ext cx="548640" cy="658368"/>
           </a:xfrm>
           <a:prstGeom prst="rect">
@@ -3657,7 +3250,7 @@
         </p:nvSpPr>
         <p:spPr>
           <a:xfrm>
-            <a:off x="6912864" y="3273552"/>
+            <a:off x="6912864" y="3072384"/>
             <a:ext cx="4526280" cy="658368"/>
           </a:xfrm>
           <a:prstGeom prst="rect">
@@ -3696,7 +3289,7 @@
         </p:nvSpPr>
         <p:spPr>
           <a:xfrm>
-            <a:off x="640080" y="4041648"/>
+            <a:off x="640080" y="3840480"/>
             <a:ext cx="5349240" cy="658368"/>
           </a:xfrm>
           <a:prstGeom prst="rect">
@@ -3728,7 +3321,7 @@
         </p:nvSpPr>
         <p:spPr>
           <a:xfrm>
-            <a:off x="749808" y="4041648"/>
+            <a:off x="749808" y="3840480"/>
             <a:ext cx="548640" cy="658368"/>
           </a:xfrm>
           <a:prstGeom prst="rect">
@@ -3767,7 +3360,7 @@
         </p:nvSpPr>
         <p:spPr>
           <a:xfrm>
-            <a:off x="1353312" y="4041648"/>
+            <a:off x="1353312" y="3840480"/>
             <a:ext cx="4526280" cy="658368"/>
           </a:xfrm>
           <a:prstGeom prst="rect">
@@ -3806,7 +3399,7 @@
         </p:nvSpPr>
         <p:spPr>
           <a:xfrm>
-            <a:off x="6199632" y="4041648"/>
+            <a:off x="6199632" y="3840480"/>
             <a:ext cx="5349240" cy="658368"/>
           </a:xfrm>
           <a:prstGeom prst="rect">
@@ -3838,7 +3431,7 @@
         </p:nvSpPr>
         <p:spPr>
           <a:xfrm>
-            <a:off x="6309360" y="4041648"/>
+            <a:off x="6309360" y="3840480"/>
             <a:ext cx="548640" cy="658368"/>
           </a:xfrm>
           <a:prstGeom prst="rect">
@@ -3877,7 +3470,7 @@
         </p:nvSpPr>
         <p:spPr>
           <a:xfrm>
-            <a:off x="6912864" y="4041648"/>
+            <a:off x="6912864" y="3840480"/>
             <a:ext cx="4526280" cy="658368"/>
           </a:xfrm>
           <a:prstGeom prst="rect">
@@ -3916,7 +3509,7 @@
         </p:nvSpPr>
         <p:spPr>
           <a:xfrm>
-            <a:off x="640080" y="4809744"/>
+            <a:off x="640080" y="4608576"/>
             <a:ext cx="5349240" cy="658368"/>
           </a:xfrm>
           <a:prstGeom prst="rect">
@@ -3948,7 +3541,7 @@
         </p:nvSpPr>
         <p:spPr>
           <a:xfrm>
-            <a:off x="749808" y="4809744"/>
+            <a:off x="749808" y="4608576"/>
             <a:ext cx="548640" cy="658368"/>
           </a:xfrm>
           <a:prstGeom prst="rect">
@@ -3987,7 +3580,7 @@
         </p:nvSpPr>
         <p:spPr>
           <a:xfrm>
-            <a:off x="1353312" y="4809744"/>
+            <a:off x="1353312" y="4608576"/>
             <a:ext cx="4526280" cy="658368"/>
           </a:xfrm>
           <a:prstGeom prst="rect">
@@ -4026,7 +3619,7 @@
         </p:nvSpPr>
         <p:spPr>
           <a:xfrm>
-            <a:off x="6199632" y="4809744"/>
+            <a:off x="6199632" y="4608576"/>
             <a:ext cx="5349240" cy="658368"/>
           </a:xfrm>
           <a:prstGeom prst="rect">
@@ -4058,7 +3651,7 @@
         </p:nvSpPr>
         <p:spPr>
           <a:xfrm>
-            <a:off x="6309360" y="4809744"/>
+            <a:off x="6309360" y="4608576"/>
             <a:ext cx="548640" cy="658368"/>
           </a:xfrm>
           <a:prstGeom prst="rect">
@@ -4097,7 +3690,7 @@
         </p:nvSpPr>
         <p:spPr>
           <a:xfrm>
-            <a:off x="6912864" y="4809744"/>
+            <a:off x="6912864" y="4608576"/>
             <a:ext cx="4526280" cy="658368"/>
           </a:xfrm>
           <a:prstGeom prst="rect">
@@ -4136,7 +3729,7 @@
         </p:nvSpPr>
         <p:spPr>
           <a:xfrm>
-            <a:off x="640080" y="5577840"/>
+            <a:off x="640080" y="5376672"/>
             <a:ext cx="5349240" cy="658368"/>
           </a:xfrm>
           <a:prstGeom prst="rect">
@@ -4168,7 +3761,7 @@
         </p:nvSpPr>
         <p:spPr>
           <a:xfrm>
-            <a:off x="749808" y="5577840"/>
+            <a:off x="749808" y="5376672"/>
             <a:ext cx="548640" cy="658368"/>
           </a:xfrm>
           <a:prstGeom prst="rect">
@@ -4207,7 +3800,7 @@
         </p:nvSpPr>
         <p:spPr>
           <a:xfrm>
-            <a:off x="1353312" y="5577840"/>
+            <a:off x="1353312" y="5376672"/>
             <a:ext cx="4526280" cy="658368"/>
           </a:xfrm>
           <a:prstGeom prst="rect">
@@ -4246,7 +3839,7 @@
         </p:nvSpPr>
         <p:spPr>
           <a:xfrm>
-            <a:off x="6199632" y="5577840"/>
+            <a:off x="6199632" y="5376672"/>
             <a:ext cx="5349240" cy="658368"/>
           </a:xfrm>
           <a:prstGeom prst="rect">
@@ -4278,7 +3871,7 @@
         </p:nvSpPr>
         <p:spPr>
           <a:xfrm>
-            <a:off x="6309360" y="5577840"/>
+            <a:off x="6309360" y="5376672"/>
             <a:ext cx="548640" cy="658368"/>
           </a:xfrm>
           <a:prstGeom prst="rect">
@@ -4317,7 +3910,7 @@
         </p:nvSpPr>
         <p:spPr>
           <a:xfrm>
-            <a:off x="6912864" y="5577840"/>
+            <a:off x="6912864" y="5376672"/>
             <a:ext cx="4526280" cy="658368"/>
           </a:xfrm>
           <a:prstGeom prst="rect">
@@ -4345,45 +3938,6 @@
               <a:t>Emergency stop button; resume after reset</a:t>
             </a:r>
             <a:endParaRPr lang="en-US" sz="1300" dirty="0"/>
-          </a:p>
-        </p:txBody>
-      </p:sp>
-      <p:sp>
-        <p:nvSpPr>
-          <p:cNvPr id="45" name="Text 42"/>
-          <p:cNvSpPr/>
-          <p:nvPr/>
-        </p:nvSpPr>
-        <p:spPr>
-          <a:xfrm>
-            <a:off x="640080" y="6355080"/>
-            <a:ext cx="10972800" cy="274320"/>
-          </a:xfrm>
-          <a:prstGeom prst="rect">
-            <a:avLst/>
-          </a:prstGeom>
-          <a:noFill/>
-          <a:ln/>
-        </p:spPr>
-        <p:txBody>
-          <a:bodyPr wrap="square" lIns="0" tIns="0" rIns="0" bIns="0" rtlCol="0" anchor="ctr"/>
-          <a:lstStyle/>
-          <a:p>
-            <a:pPr marL="0" indent="0">
-              <a:buNone/>
-            </a:pPr>
-            <a:r>
-              <a:rPr lang="en-US" sz="1150" i="1" dirty="0">
-                <a:solidFill>
-                  <a:srgbClr val="6E6E6C"/>
-                </a:solidFill>
-                <a:latin typeface="Arial" pitchFamily="34" charset="0"/>
-                <a:ea typeface="Arial" pitchFamily="34" charset="-122"/>
-                <a:cs typeface="Arial" pitchFamily="34" charset="-120"/>
-              </a:rPr>
-              <a:t>Together these define collective control (SCAN) — the focus of this part.</a:t>
-            </a:r>
-            <a:endParaRPr lang="en-US" sz="1150" dirty="0"/>
           </a:p>
         </p:txBody>
       </p:sp>
@@ -4392,6 +3946,1118 @@
   <p:clrMapOvr>
     <a:masterClrMapping/>
   </p:clrMapOvr>
+  <p:timing>
+    <p:tnLst>
+      <p:par>
+        <p:cTn id="1" dur="indefinite" restart="never" nodeType="tmRoot">
+          <p:childTnLst>
+            <p:seq concurrent="1" nextAc="seek">
+              <p:cTn id="2" dur="indefinite" nodeType="mainSeq">
+                <p:childTnLst>
+                  <p:par>
+                    <p:cTn id="3" fill="hold">
+                      <p:stCondLst>
+                        <p:cond delay="indefinite"/>
+                      </p:stCondLst>
+                      <p:childTnLst>
+                        <p:par>
+                          <p:cTn id="4" fill="hold">
+                            <p:stCondLst>
+                              <p:cond delay="0"/>
+                            </p:stCondLst>
+                            <p:childTnLst>
+                              <p:par>
+                                <p:cTn id="5" presetID="1" presetClass="entr" presetSubtype="0" fill="hold" grpId="0" nodeType="clickEffect">
+                                  <p:stCondLst>
+                                    <p:cond delay="0"/>
+                                  </p:stCondLst>
+                                  <p:childTnLst>
+                                    <p:set>
+                                      <p:cBhvr>
+                                        <p:cTn id="6" dur="1" fill="hold">
+                                          <p:stCondLst>
+                                            <p:cond delay="0"/>
+                                          </p:stCondLst>
+                                        </p:cTn>
+                                        <p:tgtEl>
+                                          <p:spTgt spid="9"/>
+                                        </p:tgtEl>
+                                        <p:attrNameLst>
+                                          <p:attrName>style.visibility</p:attrName>
+                                        </p:attrNameLst>
+                                      </p:cBhvr>
+                                      <p:to>
+                                        <p:strVal val="visible"/>
+                                      </p:to>
+                                    </p:set>
+                                  </p:childTnLst>
+                                </p:cTn>
+                              </p:par>
+                              <p:par>
+                                <p:cTn id="7" presetID="1" presetClass="entr" presetSubtype="0" fill="hold" grpId="0" nodeType="withEffect">
+                                  <p:stCondLst>
+                                    <p:cond delay="0"/>
+                                  </p:stCondLst>
+                                  <p:childTnLst>
+                                    <p:set>
+                                      <p:cBhvr>
+                                        <p:cTn id="8" dur="1" fill="hold">
+                                          <p:stCondLst>
+                                            <p:cond delay="0"/>
+                                          </p:stCondLst>
+                                        </p:cTn>
+                                        <p:tgtEl>
+                                          <p:spTgt spid="10"/>
+                                        </p:tgtEl>
+                                        <p:attrNameLst>
+                                          <p:attrName>style.visibility</p:attrName>
+                                        </p:attrNameLst>
+                                      </p:cBhvr>
+                                      <p:to>
+                                        <p:strVal val="visible"/>
+                                      </p:to>
+                                    </p:set>
+                                  </p:childTnLst>
+                                </p:cTn>
+                              </p:par>
+                              <p:par>
+                                <p:cTn id="9" presetID="1" presetClass="entr" presetSubtype="0" fill="hold" grpId="0" nodeType="withEffect">
+                                  <p:stCondLst>
+                                    <p:cond delay="0"/>
+                                  </p:stCondLst>
+                                  <p:childTnLst>
+                                    <p:set>
+                                      <p:cBhvr>
+                                        <p:cTn id="10" dur="1" fill="hold">
+                                          <p:stCondLst>
+                                            <p:cond delay="0"/>
+                                          </p:stCondLst>
+                                        </p:cTn>
+                                        <p:tgtEl>
+                                          <p:spTgt spid="11"/>
+                                        </p:tgtEl>
+                                        <p:attrNameLst>
+                                          <p:attrName>style.visibility</p:attrName>
+                                        </p:attrNameLst>
+                                      </p:cBhvr>
+                                      <p:to>
+                                        <p:strVal val="visible"/>
+                                      </p:to>
+                                    </p:set>
+                                  </p:childTnLst>
+                                </p:cTn>
+                              </p:par>
+                              <p:par>
+                                <p:cTn id="11" presetID="1" presetClass="entr" presetSubtype="0" fill="hold" grpId="0" nodeType="withEffect">
+                                  <p:stCondLst>
+                                    <p:cond delay="0"/>
+                                  </p:stCondLst>
+                                  <p:childTnLst>
+                                    <p:set>
+                                      <p:cBhvr>
+                                        <p:cTn id="12" dur="1" fill="hold">
+                                          <p:stCondLst>
+                                            <p:cond delay="0"/>
+                                          </p:stCondLst>
+                                        </p:cTn>
+                                        <p:tgtEl>
+                                          <p:spTgt spid="12"/>
+                                        </p:tgtEl>
+                                        <p:attrNameLst>
+                                          <p:attrName>style.visibility</p:attrName>
+                                        </p:attrNameLst>
+                                      </p:cBhvr>
+                                      <p:to>
+                                        <p:strVal val="visible"/>
+                                      </p:to>
+                                    </p:set>
+                                  </p:childTnLst>
+                                </p:cTn>
+                              </p:par>
+                              <p:par>
+                                <p:cTn id="13" presetID="1" presetClass="entr" presetSubtype="0" fill="hold" grpId="0" nodeType="withEffect">
+                                  <p:stCondLst>
+                                    <p:cond delay="0"/>
+                                  </p:stCondLst>
+                                  <p:childTnLst>
+                                    <p:set>
+                                      <p:cBhvr>
+                                        <p:cTn id="14" dur="1" fill="hold">
+                                          <p:stCondLst>
+                                            <p:cond delay="0"/>
+                                          </p:stCondLst>
+                                        </p:cTn>
+                                        <p:tgtEl>
+                                          <p:spTgt spid="13"/>
+                                        </p:tgtEl>
+                                        <p:attrNameLst>
+                                          <p:attrName>style.visibility</p:attrName>
+                                        </p:attrNameLst>
+                                      </p:cBhvr>
+                                      <p:to>
+                                        <p:strVal val="visible"/>
+                                      </p:to>
+                                    </p:set>
+                                  </p:childTnLst>
+                                </p:cTn>
+                              </p:par>
+                              <p:par>
+                                <p:cTn id="15" presetID="1" presetClass="entr" presetSubtype="0" fill="hold" grpId="0" nodeType="withEffect">
+                                  <p:stCondLst>
+                                    <p:cond delay="0"/>
+                                  </p:stCondLst>
+                                  <p:childTnLst>
+                                    <p:set>
+                                      <p:cBhvr>
+                                        <p:cTn id="16" dur="1" fill="hold">
+                                          <p:stCondLst>
+                                            <p:cond delay="0"/>
+                                          </p:stCondLst>
+                                        </p:cTn>
+                                        <p:tgtEl>
+                                          <p:spTgt spid="14"/>
+                                        </p:tgtEl>
+                                        <p:attrNameLst>
+                                          <p:attrName>style.visibility</p:attrName>
+                                        </p:attrNameLst>
+                                      </p:cBhvr>
+                                      <p:to>
+                                        <p:strVal val="visible"/>
+                                      </p:to>
+                                    </p:set>
+                                  </p:childTnLst>
+                                </p:cTn>
+                              </p:par>
+                              <p:par>
+                                <p:cTn id="17" presetID="1" presetClass="entr" presetSubtype="0" fill="hold" grpId="0" nodeType="withEffect">
+                                  <p:stCondLst>
+                                    <p:cond delay="0"/>
+                                  </p:stCondLst>
+                                  <p:childTnLst>
+                                    <p:set>
+                                      <p:cBhvr>
+                                        <p:cTn id="18" dur="1" fill="hold">
+                                          <p:stCondLst>
+                                            <p:cond delay="0"/>
+                                          </p:stCondLst>
+                                        </p:cTn>
+                                        <p:tgtEl>
+                                          <p:spTgt spid="15"/>
+                                        </p:tgtEl>
+                                        <p:attrNameLst>
+                                          <p:attrName>style.visibility</p:attrName>
+                                        </p:attrNameLst>
+                                      </p:cBhvr>
+                                      <p:to>
+                                        <p:strVal val="visible"/>
+                                      </p:to>
+                                    </p:set>
+                                  </p:childTnLst>
+                                </p:cTn>
+                              </p:par>
+                              <p:par>
+                                <p:cTn id="19" presetID="1" presetClass="entr" presetSubtype="0" fill="hold" grpId="0" nodeType="withEffect">
+                                  <p:stCondLst>
+                                    <p:cond delay="0"/>
+                                  </p:stCondLst>
+                                  <p:childTnLst>
+                                    <p:set>
+                                      <p:cBhvr>
+                                        <p:cTn id="20" dur="1" fill="hold">
+                                          <p:stCondLst>
+                                            <p:cond delay="0"/>
+                                          </p:stCondLst>
+                                        </p:cTn>
+                                        <p:tgtEl>
+                                          <p:spTgt spid="16"/>
+                                        </p:tgtEl>
+                                        <p:attrNameLst>
+                                          <p:attrName>style.visibility</p:attrName>
+                                        </p:attrNameLst>
+                                      </p:cBhvr>
+                                      <p:to>
+                                        <p:strVal val="visible"/>
+                                      </p:to>
+                                    </p:set>
+                                  </p:childTnLst>
+                                </p:cTn>
+                              </p:par>
+                              <p:par>
+                                <p:cTn id="21" presetID="1" presetClass="entr" presetSubtype="0" fill="hold" grpId="0" nodeType="withEffect">
+                                  <p:stCondLst>
+                                    <p:cond delay="0"/>
+                                  </p:stCondLst>
+                                  <p:childTnLst>
+                                    <p:set>
+                                      <p:cBhvr>
+                                        <p:cTn id="22" dur="1" fill="hold">
+                                          <p:stCondLst>
+                                            <p:cond delay="0"/>
+                                          </p:stCondLst>
+                                        </p:cTn>
+                                        <p:tgtEl>
+                                          <p:spTgt spid="17"/>
+                                        </p:tgtEl>
+                                        <p:attrNameLst>
+                                          <p:attrName>style.visibility</p:attrName>
+                                        </p:attrNameLst>
+                                      </p:cBhvr>
+                                      <p:to>
+                                        <p:strVal val="visible"/>
+                                      </p:to>
+                                    </p:set>
+                                  </p:childTnLst>
+                                </p:cTn>
+                              </p:par>
+                              <p:par>
+                                <p:cTn id="23" presetID="1" presetClass="entr" presetSubtype="0" fill="hold" grpId="0" nodeType="withEffect">
+                                  <p:stCondLst>
+                                    <p:cond delay="0"/>
+                                  </p:stCondLst>
+                                  <p:childTnLst>
+                                    <p:set>
+                                      <p:cBhvr>
+                                        <p:cTn id="24" dur="1" fill="hold">
+                                          <p:stCondLst>
+                                            <p:cond delay="0"/>
+                                          </p:stCondLst>
+                                        </p:cTn>
+                                        <p:tgtEl>
+                                          <p:spTgt spid="18"/>
+                                        </p:tgtEl>
+                                        <p:attrNameLst>
+                                          <p:attrName>style.visibility</p:attrName>
+                                        </p:attrNameLst>
+                                      </p:cBhvr>
+                                      <p:to>
+                                        <p:strVal val="visible"/>
+                                      </p:to>
+                                    </p:set>
+                                  </p:childTnLst>
+                                </p:cTn>
+                              </p:par>
+                              <p:par>
+                                <p:cTn id="25" presetID="1" presetClass="entr" presetSubtype="0" fill="hold" grpId="0" nodeType="withEffect">
+                                  <p:stCondLst>
+                                    <p:cond delay="0"/>
+                                  </p:stCondLst>
+                                  <p:childTnLst>
+                                    <p:set>
+                                      <p:cBhvr>
+                                        <p:cTn id="26" dur="1" fill="hold">
+                                          <p:stCondLst>
+                                            <p:cond delay="0"/>
+                                          </p:stCondLst>
+                                        </p:cTn>
+                                        <p:tgtEl>
+                                          <p:spTgt spid="19"/>
+                                        </p:tgtEl>
+                                        <p:attrNameLst>
+                                          <p:attrName>style.visibility</p:attrName>
+                                        </p:attrNameLst>
+                                      </p:cBhvr>
+                                      <p:to>
+                                        <p:strVal val="visible"/>
+                                      </p:to>
+                                    </p:set>
+                                  </p:childTnLst>
+                                </p:cTn>
+                              </p:par>
+                              <p:par>
+                                <p:cTn id="27" presetID="1" presetClass="entr" presetSubtype="0" fill="hold" grpId="0" nodeType="withEffect">
+                                  <p:stCondLst>
+                                    <p:cond delay="0"/>
+                                  </p:stCondLst>
+                                  <p:childTnLst>
+                                    <p:set>
+                                      <p:cBhvr>
+                                        <p:cTn id="28" dur="1" fill="hold">
+                                          <p:stCondLst>
+                                            <p:cond delay="0"/>
+                                          </p:stCondLst>
+                                        </p:cTn>
+                                        <p:tgtEl>
+                                          <p:spTgt spid="20"/>
+                                        </p:tgtEl>
+                                        <p:attrNameLst>
+                                          <p:attrName>style.visibility</p:attrName>
+                                        </p:attrNameLst>
+                                      </p:cBhvr>
+                                      <p:to>
+                                        <p:strVal val="visible"/>
+                                      </p:to>
+                                    </p:set>
+                                  </p:childTnLst>
+                                </p:cTn>
+                              </p:par>
+                              <p:par>
+                                <p:cTn id="29" presetID="1" presetClass="entr" presetSubtype="0" fill="hold" grpId="0" nodeType="withEffect">
+                                  <p:stCondLst>
+                                    <p:cond delay="0"/>
+                                  </p:stCondLst>
+                                  <p:childTnLst>
+                                    <p:set>
+                                      <p:cBhvr>
+                                        <p:cTn id="30" dur="1" fill="hold">
+                                          <p:stCondLst>
+                                            <p:cond delay="0"/>
+                                          </p:stCondLst>
+                                        </p:cTn>
+                                        <p:tgtEl>
+                                          <p:spTgt spid="23"/>
+                                        </p:tgtEl>
+                                        <p:attrNameLst>
+                                          <p:attrName>style.visibility</p:attrName>
+                                        </p:attrNameLst>
+                                      </p:cBhvr>
+                                      <p:to>
+                                        <p:strVal val="visible"/>
+                                      </p:to>
+                                    </p:set>
+                                  </p:childTnLst>
+                                </p:cTn>
+                              </p:par>
+                              <p:par>
+                                <p:cTn id="31" presetID="1" presetClass="entr" presetSubtype="0" fill="hold" grpId="0" nodeType="withEffect">
+                                  <p:stCondLst>
+                                    <p:cond delay="0"/>
+                                  </p:stCondLst>
+                                  <p:childTnLst>
+                                    <p:set>
+                                      <p:cBhvr>
+                                        <p:cTn id="32" dur="1" fill="hold">
+                                          <p:stCondLst>
+                                            <p:cond delay="0"/>
+                                          </p:stCondLst>
+                                        </p:cTn>
+                                        <p:tgtEl>
+                                          <p:spTgt spid="21"/>
+                                        </p:tgtEl>
+                                        <p:attrNameLst>
+                                          <p:attrName>style.visibility</p:attrName>
+                                        </p:attrNameLst>
+                                      </p:cBhvr>
+                                      <p:to>
+                                        <p:strVal val="visible"/>
+                                      </p:to>
+                                    </p:set>
+                                  </p:childTnLst>
+                                </p:cTn>
+                              </p:par>
+                              <p:par>
+                                <p:cTn id="33" presetID="1" presetClass="entr" presetSubtype="0" fill="hold" grpId="0" nodeType="withEffect">
+                                  <p:stCondLst>
+                                    <p:cond delay="0"/>
+                                  </p:stCondLst>
+                                  <p:childTnLst>
+                                    <p:set>
+                                      <p:cBhvr>
+                                        <p:cTn id="34" dur="1" fill="hold">
+                                          <p:stCondLst>
+                                            <p:cond delay="0"/>
+                                          </p:stCondLst>
+                                        </p:cTn>
+                                        <p:tgtEl>
+                                          <p:spTgt spid="22"/>
+                                        </p:tgtEl>
+                                        <p:attrNameLst>
+                                          <p:attrName>style.visibility</p:attrName>
+                                        </p:attrNameLst>
+                                      </p:cBhvr>
+                                      <p:to>
+                                        <p:strVal val="visible"/>
+                                      </p:to>
+                                    </p:set>
+                                  </p:childTnLst>
+                                </p:cTn>
+                              </p:par>
+                            </p:childTnLst>
+                          </p:cTn>
+                        </p:par>
+                      </p:childTnLst>
+                    </p:cTn>
+                  </p:par>
+                  <p:par>
+                    <p:cTn id="35" fill="hold">
+                      <p:stCondLst>
+                        <p:cond delay="indefinite"/>
+                      </p:stCondLst>
+                      <p:childTnLst>
+                        <p:par>
+                          <p:cTn id="36" fill="hold">
+                            <p:stCondLst>
+                              <p:cond delay="0"/>
+                            </p:stCondLst>
+                            <p:childTnLst>
+                              <p:par>
+                                <p:cTn id="37" presetID="1" presetClass="entr" presetSubtype="0" fill="hold" grpId="0" nodeType="clickEffect">
+                                  <p:stCondLst>
+                                    <p:cond delay="0"/>
+                                  </p:stCondLst>
+                                  <p:childTnLst>
+                                    <p:set>
+                                      <p:cBhvr>
+                                        <p:cTn id="38" dur="1" fill="hold">
+                                          <p:stCondLst>
+                                            <p:cond delay="0"/>
+                                          </p:stCondLst>
+                                        </p:cTn>
+                                        <p:tgtEl>
+                                          <p:spTgt spid="24"/>
+                                        </p:tgtEl>
+                                        <p:attrNameLst>
+                                          <p:attrName>style.visibility</p:attrName>
+                                        </p:attrNameLst>
+                                      </p:cBhvr>
+                                      <p:to>
+                                        <p:strVal val="visible"/>
+                                      </p:to>
+                                    </p:set>
+                                  </p:childTnLst>
+                                </p:cTn>
+                              </p:par>
+                              <p:par>
+                                <p:cTn id="39" presetID="1" presetClass="entr" presetSubtype="0" fill="hold" grpId="0" nodeType="withEffect">
+                                  <p:stCondLst>
+                                    <p:cond delay="0"/>
+                                  </p:stCondLst>
+                                  <p:childTnLst>
+                                    <p:set>
+                                      <p:cBhvr>
+                                        <p:cTn id="40" dur="1" fill="hold">
+                                          <p:stCondLst>
+                                            <p:cond delay="0"/>
+                                          </p:stCondLst>
+                                        </p:cTn>
+                                        <p:tgtEl>
+                                          <p:spTgt spid="25"/>
+                                        </p:tgtEl>
+                                        <p:attrNameLst>
+                                          <p:attrName>style.visibility</p:attrName>
+                                        </p:attrNameLst>
+                                      </p:cBhvr>
+                                      <p:to>
+                                        <p:strVal val="visible"/>
+                                      </p:to>
+                                    </p:set>
+                                  </p:childTnLst>
+                                </p:cTn>
+                              </p:par>
+                              <p:par>
+                                <p:cTn id="41" presetID="1" presetClass="entr" presetSubtype="0" fill="hold" grpId="0" nodeType="withEffect">
+                                  <p:stCondLst>
+                                    <p:cond delay="0"/>
+                                  </p:stCondLst>
+                                  <p:childTnLst>
+                                    <p:set>
+                                      <p:cBhvr>
+                                        <p:cTn id="42" dur="1" fill="hold">
+                                          <p:stCondLst>
+                                            <p:cond delay="0"/>
+                                          </p:stCondLst>
+                                        </p:cTn>
+                                        <p:tgtEl>
+                                          <p:spTgt spid="26"/>
+                                        </p:tgtEl>
+                                        <p:attrNameLst>
+                                          <p:attrName>style.visibility</p:attrName>
+                                        </p:attrNameLst>
+                                      </p:cBhvr>
+                                      <p:to>
+                                        <p:strVal val="visible"/>
+                                      </p:to>
+                                    </p:set>
+                                  </p:childTnLst>
+                                </p:cTn>
+                              </p:par>
+                              <p:par>
+                                <p:cTn id="43" presetID="1" presetClass="entr" presetSubtype="0" fill="hold" grpId="0" nodeType="withEffect">
+                                  <p:stCondLst>
+                                    <p:cond delay="0"/>
+                                  </p:stCondLst>
+                                  <p:childTnLst>
+                                    <p:set>
+                                      <p:cBhvr>
+                                        <p:cTn id="44" dur="1" fill="hold">
+                                          <p:stCondLst>
+                                            <p:cond delay="0"/>
+                                          </p:stCondLst>
+                                        </p:cTn>
+                                        <p:tgtEl>
+                                          <p:spTgt spid="27"/>
+                                        </p:tgtEl>
+                                        <p:attrNameLst>
+                                          <p:attrName>style.visibility</p:attrName>
+                                        </p:attrNameLst>
+                                      </p:cBhvr>
+                                      <p:to>
+                                        <p:strVal val="visible"/>
+                                      </p:to>
+                                    </p:set>
+                                  </p:childTnLst>
+                                </p:cTn>
+                              </p:par>
+                              <p:par>
+                                <p:cTn id="45" presetID="1" presetClass="entr" presetSubtype="0" fill="hold" grpId="0" nodeType="withEffect">
+                                  <p:stCondLst>
+                                    <p:cond delay="0"/>
+                                  </p:stCondLst>
+                                  <p:childTnLst>
+                                    <p:set>
+                                      <p:cBhvr>
+                                        <p:cTn id="46" dur="1" fill="hold">
+                                          <p:stCondLst>
+                                            <p:cond delay="0"/>
+                                          </p:stCondLst>
+                                        </p:cTn>
+                                        <p:tgtEl>
+                                          <p:spTgt spid="29"/>
+                                        </p:tgtEl>
+                                        <p:attrNameLst>
+                                          <p:attrName>style.visibility</p:attrName>
+                                        </p:attrNameLst>
+                                      </p:cBhvr>
+                                      <p:to>
+                                        <p:strVal val="visible"/>
+                                      </p:to>
+                                    </p:set>
+                                  </p:childTnLst>
+                                </p:cTn>
+                              </p:par>
+                              <p:par>
+                                <p:cTn id="47" presetID="1" presetClass="entr" presetSubtype="0" fill="hold" grpId="0" nodeType="withEffect">
+                                  <p:stCondLst>
+                                    <p:cond delay="0"/>
+                                  </p:stCondLst>
+                                  <p:childTnLst>
+                                    <p:set>
+                                      <p:cBhvr>
+                                        <p:cTn id="48" dur="1" fill="hold">
+                                          <p:stCondLst>
+                                            <p:cond delay="0"/>
+                                          </p:stCondLst>
+                                        </p:cTn>
+                                        <p:tgtEl>
+                                          <p:spTgt spid="28"/>
+                                        </p:tgtEl>
+                                        <p:attrNameLst>
+                                          <p:attrName>style.visibility</p:attrName>
+                                        </p:attrNameLst>
+                                      </p:cBhvr>
+                                      <p:to>
+                                        <p:strVal val="visible"/>
+                                      </p:to>
+                                    </p:set>
+                                  </p:childTnLst>
+                                </p:cTn>
+                              </p:par>
+                            </p:childTnLst>
+                          </p:cTn>
+                        </p:par>
+                      </p:childTnLst>
+                    </p:cTn>
+                  </p:par>
+                  <p:par>
+                    <p:cTn id="49" fill="hold">
+                      <p:stCondLst>
+                        <p:cond delay="indefinite"/>
+                      </p:stCondLst>
+                      <p:childTnLst>
+                        <p:par>
+                          <p:cTn id="50" fill="hold">
+                            <p:stCondLst>
+                              <p:cond delay="0"/>
+                            </p:stCondLst>
+                            <p:childTnLst>
+                              <p:par>
+                                <p:cTn id="51" presetID="1" presetClass="entr" presetSubtype="0" fill="hold" grpId="0" nodeType="clickEffect">
+                                  <p:stCondLst>
+                                    <p:cond delay="0"/>
+                                  </p:stCondLst>
+                                  <p:childTnLst>
+                                    <p:set>
+                                      <p:cBhvr>
+                                        <p:cTn id="52" dur="1" fill="hold">
+                                          <p:stCondLst>
+                                            <p:cond delay="0"/>
+                                          </p:stCondLst>
+                                        </p:cTn>
+                                        <p:tgtEl>
+                                          <p:spTgt spid="30"/>
+                                        </p:tgtEl>
+                                        <p:attrNameLst>
+                                          <p:attrName>style.visibility</p:attrName>
+                                        </p:attrNameLst>
+                                      </p:cBhvr>
+                                      <p:to>
+                                        <p:strVal val="visible"/>
+                                      </p:to>
+                                    </p:set>
+                                  </p:childTnLst>
+                                </p:cTn>
+                              </p:par>
+                              <p:par>
+                                <p:cTn id="53" presetID="1" presetClass="entr" presetSubtype="0" fill="hold" grpId="0" nodeType="withEffect">
+                                  <p:stCondLst>
+                                    <p:cond delay="0"/>
+                                  </p:stCondLst>
+                                  <p:childTnLst>
+                                    <p:set>
+                                      <p:cBhvr>
+                                        <p:cTn id="54" dur="1" fill="hold">
+                                          <p:stCondLst>
+                                            <p:cond delay="0"/>
+                                          </p:stCondLst>
+                                        </p:cTn>
+                                        <p:tgtEl>
+                                          <p:spTgt spid="31"/>
+                                        </p:tgtEl>
+                                        <p:attrNameLst>
+                                          <p:attrName>style.visibility</p:attrName>
+                                        </p:attrNameLst>
+                                      </p:cBhvr>
+                                      <p:to>
+                                        <p:strVal val="visible"/>
+                                      </p:to>
+                                    </p:set>
+                                  </p:childTnLst>
+                                </p:cTn>
+                              </p:par>
+                              <p:par>
+                                <p:cTn id="55" presetID="1" presetClass="entr" presetSubtype="0" fill="hold" grpId="0" nodeType="withEffect">
+                                  <p:stCondLst>
+                                    <p:cond delay="0"/>
+                                  </p:stCondLst>
+                                  <p:childTnLst>
+                                    <p:set>
+                                      <p:cBhvr>
+                                        <p:cTn id="56" dur="1" fill="hold">
+                                          <p:stCondLst>
+                                            <p:cond delay="0"/>
+                                          </p:stCondLst>
+                                        </p:cTn>
+                                        <p:tgtEl>
+                                          <p:spTgt spid="32"/>
+                                        </p:tgtEl>
+                                        <p:attrNameLst>
+                                          <p:attrName>style.visibility</p:attrName>
+                                        </p:attrNameLst>
+                                      </p:cBhvr>
+                                      <p:to>
+                                        <p:strVal val="visible"/>
+                                      </p:to>
+                                    </p:set>
+                                  </p:childTnLst>
+                                </p:cTn>
+                              </p:par>
+                              <p:par>
+                                <p:cTn id="57" presetID="1" presetClass="entr" presetSubtype="0" fill="hold" grpId="0" nodeType="withEffect">
+                                  <p:stCondLst>
+                                    <p:cond delay="0"/>
+                                  </p:stCondLst>
+                                  <p:childTnLst>
+                                    <p:set>
+                                      <p:cBhvr>
+                                        <p:cTn id="58" dur="1" fill="hold">
+                                          <p:stCondLst>
+                                            <p:cond delay="0"/>
+                                          </p:stCondLst>
+                                        </p:cTn>
+                                        <p:tgtEl>
+                                          <p:spTgt spid="36"/>
+                                        </p:tgtEl>
+                                        <p:attrNameLst>
+                                          <p:attrName>style.visibility</p:attrName>
+                                        </p:attrNameLst>
+                                      </p:cBhvr>
+                                      <p:to>
+                                        <p:strVal val="visible"/>
+                                      </p:to>
+                                    </p:set>
+                                  </p:childTnLst>
+                                </p:cTn>
+                              </p:par>
+                              <p:par>
+                                <p:cTn id="59" presetID="1" presetClass="entr" presetSubtype="0" fill="hold" grpId="0" nodeType="withEffect">
+                                  <p:stCondLst>
+                                    <p:cond delay="0"/>
+                                  </p:stCondLst>
+                                  <p:childTnLst>
+                                    <p:set>
+                                      <p:cBhvr>
+                                        <p:cTn id="60" dur="1" fill="hold">
+                                          <p:stCondLst>
+                                            <p:cond delay="0"/>
+                                          </p:stCondLst>
+                                        </p:cTn>
+                                        <p:tgtEl>
+                                          <p:spTgt spid="37"/>
+                                        </p:tgtEl>
+                                        <p:attrNameLst>
+                                          <p:attrName>style.visibility</p:attrName>
+                                        </p:attrNameLst>
+                                      </p:cBhvr>
+                                      <p:to>
+                                        <p:strVal val="visible"/>
+                                      </p:to>
+                                    </p:set>
+                                  </p:childTnLst>
+                                </p:cTn>
+                              </p:par>
+                              <p:par>
+                                <p:cTn id="61" presetID="1" presetClass="entr" presetSubtype="0" fill="hold" grpId="0" nodeType="withEffect">
+                                  <p:stCondLst>
+                                    <p:cond delay="0"/>
+                                  </p:stCondLst>
+                                  <p:childTnLst>
+                                    <p:set>
+                                      <p:cBhvr>
+                                        <p:cTn id="62" dur="1" fill="hold">
+                                          <p:stCondLst>
+                                            <p:cond delay="0"/>
+                                          </p:stCondLst>
+                                        </p:cTn>
+                                        <p:tgtEl>
+                                          <p:spTgt spid="38"/>
+                                        </p:tgtEl>
+                                        <p:attrNameLst>
+                                          <p:attrName>style.visibility</p:attrName>
+                                        </p:attrNameLst>
+                                      </p:cBhvr>
+                                      <p:to>
+                                        <p:strVal val="visible"/>
+                                      </p:to>
+                                    </p:set>
+                                  </p:childTnLst>
+                                </p:cTn>
+                              </p:par>
+                              <p:par>
+                                <p:cTn id="63" presetID="1" presetClass="entr" presetSubtype="0" fill="hold" grpId="0" nodeType="withEffect">
+                                  <p:stCondLst>
+                                    <p:cond delay="0"/>
+                                  </p:stCondLst>
+                                  <p:childTnLst>
+                                    <p:set>
+                                      <p:cBhvr>
+                                        <p:cTn id="64" dur="1" fill="hold">
+                                          <p:stCondLst>
+                                            <p:cond delay="0"/>
+                                          </p:stCondLst>
+                                        </p:cTn>
+                                        <p:tgtEl>
+                                          <p:spTgt spid="34"/>
+                                        </p:tgtEl>
+                                        <p:attrNameLst>
+                                          <p:attrName>style.visibility</p:attrName>
+                                        </p:attrNameLst>
+                                      </p:cBhvr>
+                                      <p:to>
+                                        <p:strVal val="visible"/>
+                                      </p:to>
+                                    </p:set>
+                                  </p:childTnLst>
+                                </p:cTn>
+                              </p:par>
+                              <p:par>
+                                <p:cTn id="65" presetID="1" presetClass="entr" presetSubtype="0" fill="hold" grpId="0" nodeType="withEffect">
+                                  <p:stCondLst>
+                                    <p:cond delay="0"/>
+                                  </p:stCondLst>
+                                  <p:childTnLst>
+                                    <p:set>
+                                      <p:cBhvr>
+                                        <p:cTn id="66" dur="1" fill="hold">
+                                          <p:stCondLst>
+                                            <p:cond delay="0"/>
+                                          </p:stCondLst>
+                                        </p:cTn>
+                                        <p:tgtEl>
+                                          <p:spTgt spid="35"/>
+                                        </p:tgtEl>
+                                        <p:attrNameLst>
+                                          <p:attrName>style.visibility</p:attrName>
+                                        </p:attrNameLst>
+                                      </p:cBhvr>
+                                      <p:to>
+                                        <p:strVal val="visible"/>
+                                      </p:to>
+                                    </p:set>
+                                  </p:childTnLst>
+                                </p:cTn>
+                              </p:par>
+                              <p:par>
+                                <p:cTn id="67" presetID="1" presetClass="entr" presetSubtype="0" fill="hold" grpId="0" nodeType="withEffect">
+                                  <p:stCondLst>
+                                    <p:cond delay="0"/>
+                                  </p:stCondLst>
+                                  <p:childTnLst>
+                                    <p:set>
+                                      <p:cBhvr>
+                                        <p:cTn id="68" dur="1" fill="hold">
+                                          <p:stCondLst>
+                                            <p:cond delay="0"/>
+                                          </p:stCondLst>
+                                        </p:cTn>
+                                        <p:tgtEl>
+                                          <p:spTgt spid="33"/>
+                                        </p:tgtEl>
+                                        <p:attrNameLst>
+                                          <p:attrName>style.visibility</p:attrName>
+                                        </p:attrNameLst>
+                                      </p:cBhvr>
+                                      <p:to>
+                                        <p:strVal val="visible"/>
+                                      </p:to>
+                                    </p:set>
+                                  </p:childTnLst>
+                                </p:cTn>
+                              </p:par>
+                            </p:childTnLst>
+                          </p:cTn>
+                        </p:par>
+                      </p:childTnLst>
+                    </p:cTn>
+                  </p:par>
+                  <p:par>
+                    <p:cTn id="69" fill="hold">
+                      <p:stCondLst>
+                        <p:cond delay="indefinite"/>
+                      </p:stCondLst>
+                      <p:childTnLst>
+                        <p:par>
+                          <p:cTn id="70" fill="hold">
+                            <p:stCondLst>
+                              <p:cond delay="0"/>
+                            </p:stCondLst>
+                            <p:childTnLst>
+                              <p:par>
+                                <p:cTn id="71" presetID="1" presetClass="entr" presetSubtype="0" fill="hold" grpId="0" nodeType="clickEffect">
+                                  <p:stCondLst>
+                                    <p:cond delay="0"/>
+                                  </p:stCondLst>
+                                  <p:childTnLst>
+                                    <p:set>
+                                      <p:cBhvr>
+                                        <p:cTn id="72" dur="1" fill="hold">
+                                          <p:stCondLst>
+                                            <p:cond delay="0"/>
+                                          </p:stCondLst>
+                                        </p:cTn>
+                                        <p:tgtEl>
+                                          <p:spTgt spid="39"/>
+                                        </p:tgtEl>
+                                        <p:attrNameLst>
+                                          <p:attrName>style.visibility</p:attrName>
+                                        </p:attrNameLst>
+                                      </p:cBhvr>
+                                      <p:to>
+                                        <p:strVal val="visible"/>
+                                      </p:to>
+                                    </p:set>
+                                  </p:childTnLst>
+                                </p:cTn>
+                              </p:par>
+                              <p:par>
+                                <p:cTn id="73" presetID="1" presetClass="entr" presetSubtype="0" fill="hold" grpId="0" nodeType="withEffect">
+                                  <p:stCondLst>
+                                    <p:cond delay="0"/>
+                                  </p:stCondLst>
+                                  <p:childTnLst>
+                                    <p:set>
+                                      <p:cBhvr>
+                                        <p:cTn id="74" dur="1" fill="hold">
+                                          <p:stCondLst>
+                                            <p:cond delay="0"/>
+                                          </p:stCondLst>
+                                        </p:cTn>
+                                        <p:tgtEl>
+                                          <p:spTgt spid="40"/>
+                                        </p:tgtEl>
+                                        <p:attrNameLst>
+                                          <p:attrName>style.visibility</p:attrName>
+                                        </p:attrNameLst>
+                                      </p:cBhvr>
+                                      <p:to>
+                                        <p:strVal val="visible"/>
+                                      </p:to>
+                                    </p:set>
+                                  </p:childTnLst>
+                                </p:cTn>
+                              </p:par>
+                              <p:par>
+                                <p:cTn id="75" presetID="1" presetClass="entr" presetSubtype="0" fill="hold" grpId="0" nodeType="withEffect">
+                                  <p:stCondLst>
+                                    <p:cond delay="0"/>
+                                  </p:stCondLst>
+                                  <p:childTnLst>
+                                    <p:set>
+                                      <p:cBhvr>
+                                        <p:cTn id="76" dur="1" fill="hold">
+                                          <p:stCondLst>
+                                            <p:cond delay="0"/>
+                                          </p:stCondLst>
+                                        </p:cTn>
+                                        <p:tgtEl>
+                                          <p:spTgt spid="41"/>
+                                        </p:tgtEl>
+                                        <p:attrNameLst>
+                                          <p:attrName>style.visibility</p:attrName>
+                                        </p:attrNameLst>
+                                      </p:cBhvr>
+                                      <p:to>
+                                        <p:strVal val="visible"/>
+                                      </p:to>
+                                    </p:set>
+                                  </p:childTnLst>
+                                </p:cTn>
+                              </p:par>
+                              <p:par>
+                                <p:cTn id="77" presetID="1" presetClass="entr" presetSubtype="0" fill="hold" grpId="0" nodeType="withEffect">
+                                  <p:stCondLst>
+                                    <p:cond delay="0"/>
+                                  </p:stCondLst>
+                                  <p:childTnLst>
+                                    <p:set>
+                                      <p:cBhvr>
+                                        <p:cTn id="78" dur="1" fill="hold">
+                                          <p:stCondLst>
+                                            <p:cond delay="0"/>
+                                          </p:stCondLst>
+                                        </p:cTn>
+                                        <p:tgtEl>
+                                          <p:spTgt spid="42"/>
+                                        </p:tgtEl>
+                                        <p:attrNameLst>
+                                          <p:attrName>style.visibility</p:attrName>
+                                        </p:attrNameLst>
+                                      </p:cBhvr>
+                                      <p:to>
+                                        <p:strVal val="visible"/>
+                                      </p:to>
+                                    </p:set>
+                                  </p:childTnLst>
+                                </p:cTn>
+                              </p:par>
+                              <p:par>
+                                <p:cTn id="79" presetID="1" presetClass="entr" presetSubtype="0" fill="hold" grpId="0" nodeType="withEffect">
+                                  <p:stCondLst>
+                                    <p:cond delay="0"/>
+                                  </p:stCondLst>
+                                  <p:childTnLst>
+                                    <p:set>
+                                      <p:cBhvr>
+                                        <p:cTn id="80" dur="1" fill="hold">
+                                          <p:stCondLst>
+                                            <p:cond delay="0"/>
+                                          </p:stCondLst>
+                                        </p:cTn>
+                                        <p:tgtEl>
+                                          <p:spTgt spid="43"/>
+                                        </p:tgtEl>
+                                        <p:attrNameLst>
+                                          <p:attrName>style.visibility</p:attrName>
+                                        </p:attrNameLst>
+                                      </p:cBhvr>
+                                      <p:to>
+                                        <p:strVal val="visible"/>
+                                      </p:to>
+                                    </p:set>
+                                  </p:childTnLst>
+                                </p:cTn>
+                              </p:par>
+                              <p:par>
+                                <p:cTn id="81" presetID="1" presetClass="entr" presetSubtype="0" fill="hold" grpId="0" nodeType="withEffect">
+                                  <p:stCondLst>
+                                    <p:cond delay="0"/>
+                                  </p:stCondLst>
+                                  <p:childTnLst>
+                                    <p:set>
+                                      <p:cBhvr>
+                                        <p:cTn id="82" dur="1" fill="hold">
+                                          <p:stCondLst>
+                                            <p:cond delay="0"/>
+                                          </p:stCondLst>
+                                        </p:cTn>
+                                        <p:tgtEl>
+                                          <p:spTgt spid="44"/>
+                                        </p:tgtEl>
+                                        <p:attrNameLst>
+                                          <p:attrName>style.visibility</p:attrName>
+                                        </p:attrNameLst>
+                                      </p:cBhvr>
+                                      <p:to>
+                                        <p:strVal val="visible"/>
+                                      </p:to>
+                                    </p:set>
+                                  </p:childTnLst>
+                                </p:cTn>
+                              </p:par>
+                            </p:childTnLst>
+                          </p:cTn>
+                        </p:par>
+                      </p:childTnLst>
+                    </p:cTn>
+                  </p:par>
+                </p:childTnLst>
+              </p:cTn>
+              <p:prevCondLst>
+                <p:cond evt="onPrev" delay="0">
+                  <p:tgtEl>
+                    <p:sldTgt/>
+                  </p:tgtEl>
+                </p:cond>
+              </p:prevCondLst>
+              <p:nextCondLst>
+                <p:cond evt="onNext" delay="0">
+                  <p:tgtEl>
+                    <p:sldTgt/>
+                  </p:tgtEl>
+                </p:cond>
+              </p:nextCondLst>
+            </p:seq>
+          </p:childTnLst>
+        </p:cTn>
+      </p:par>
+    </p:tnLst>
+    <p:bldLst>
+      <p:bldP spid="9" grpId="0" animBg="1"/>
+      <p:bldP spid="10" grpId="0" animBg="1"/>
+      <p:bldP spid="11" grpId="0" animBg="1"/>
+      <p:bldP spid="12" grpId="0" animBg="1"/>
+      <p:bldP spid="13" grpId="0" animBg="1"/>
+      <p:bldP spid="14" grpId="0" animBg="1"/>
+      <p:bldP spid="15" grpId="0" animBg="1"/>
+      <p:bldP spid="16" grpId="0" animBg="1"/>
+      <p:bldP spid="17" grpId="0" animBg="1"/>
+      <p:bldP spid="18" grpId="0" animBg="1"/>
+      <p:bldP spid="19" grpId="0" animBg="1"/>
+      <p:bldP spid="20" grpId="0" animBg="1"/>
+      <p:bldP spid="21" grpId="0" animBg="1"/>
+      <p:bldP spid="22" grpId="0" animBg="1"/>
+      <p:bldP spid="23" grpId="0" animBg="1"/>
+      <p:bldP spid="24" grpId="0" animBg="1"/>
+      <p:bldP spid="25" grpId="0" animBg="1"/>
+      <p:bldP spid="26" grpId="0" animBg="1"/>
+      <p:bldP spid="27" grpId="0" animBg="1"/>
+      <p:bldP spid="28" grpId="0" animBg="1"/>
+      <p:bldP spid="29" grpId="0" animBg="1"/>
+      <p:bldP spid="30" grpId="0" animBg="1"/>
+      <p:bldP spid="31" grpId="0" animBg="1"/>
+      <p:bldP spid="32" grpId="0" animBg="1"/>
+      <p:bldP spid="33" grpId="0" animBg="1"/>
+      <p:bldP spid="34" grpId="0" animBg="1"/>
+      <p:bldP spid="35" grpId="0" animBg="1"/>
+      <p:bldP spid="36" grpId="0" animBg="1"/>
+      <p:bldP spid="37" grpId="0" animBg="1"/>
+      <p:bldP spid="38" grpId="0" animBg="1"/>
+      <p:bldP spid="39" grpId="0" animBg="1"/>
+      <p:bldP spid="40" grpId="0" animBg="1"/>
+      <p:bldP spid="41" grpId="0" animBg="1"/>
+      <p:bldP spid="42" grpId="0" animBg="1"/>
+      <p:bldP spid="43" grpId="0" animBg="1"/>
+      <p:bldP spid="44" grpId="0" animBg="1"/>
+    </p:bldLst>
+  </p:timing>
 </p:sld>
 </file>
 
@@ -4525,45 +5191,6 @@
           <a:lstStyle/>
           <a:p>
             <a:endParaRPr lang="de-DE"/>
-          </a:p>
-        </p:txBody>
-      </p:sp>
-      <p:sp>
-        <p:nvSpPr>
-          <p:cNvPr id="6" name="Text 4"/>
-          <p:cNvSpPr/>
-          <p:nvPr/>
-        </p:nvSpPr>
-        <p:spPr>
-          <a:xfrm>
-            <a:off x="640080" y="6437376"/>
-            <a:ext cx="8229600" cy="274320"/>
-          </a:xfrm>
-          <a:prstGeom prst="rect">
-            <a:avLst/>
-          </a:prstGeom>
-          <a:noFill/>
-          <a:ln/>
-        </p:spPr>
-        <p:txBody>
-          <a:bodyPr wrap="square" lIns="0" tIns="0" rIns="0" bIns="0" rtlCol="0" anchor="ctr"/>
-          <a:lstStyle/>
-          <a:p>
-            <a:pPr marL="0" indent="0">
-              <a:buNone/>
-            </a:pPr>
-            <a:r>
-              <a:rPr lang="en-US" sz="900" dirty="0">
-                <a:solidFill>
-                  <a:srgbClr val="6E6E6C"/>
-                </a:solidFill>
-                <a:latin typeface="Arial" pitchFamily="34" charset="0"/>
-                <a:ea typeface="Arial" pitchFamily="34" charset="-122"/>
-                <a:cs typeface="Arial" pitchFamily="34" charset="-120"/>
-              </a:rPr>
-              <a:t>HTWG Konstanz  ·  System Architecture  ·  Group E</a:t>
-            </a:r>
-            <a:endParaRPr lang="en-US" sz="900" dirty="0"/>
           </a:p>
         </p:txBody>
       </p:sp>
@@ -5478,45 +6105,6 @@
       </p:sp>
       <p:sp>
         <p:nvSpPr>
-          <p:cNvPr id="6" name="Text 4"/>
-          <p:cNvSpPr/>
-          <p:nvPr/>
-        </p:nvSpPr>
-        <p:spPr>
-          <a:xfrm>
-            <a:off x="640080" y="6437376"/>
-            <a:ext cx="8229600" cy="274320"/>
-          </a:xfrm>
-          <a:prstGeom prst="rect">
-            <a:avLst/>
-          </a:prstGeom>
-          <a:noFill/>
-          <a:ln/>
-        </p:spPr>
-        <p:txBody>
-          <a:bodyPr wrap="square" lIns="0" tIns="0" rIns="0" bIns="0" rtlCol="0" anchor="ctr"/>
-          <a:lstStyle/>
-          <a:p>
-            <a:pPr marL="0" indent="0">
-              <a:buNone/>
-            </a:pPr>
-            <a:r>
-              <a:rPr lang="en-US" sz="900" dirty="0">
-                <a:solidFill>
-                  <a:srgbClr val="6E6E6C"/>
-                </a:solidFill>
-                <a:latin typeface="Arial" pitchFamily="34" charset="0"/>
-                <a:ea typeface="Arial" pitchFamily="34" charset="-122"/>
-                <a:cs typeface="Arial" pitchFamily="34" charset="-120"/>
-              </a:rPr>
-              <a:t>HTWG Konstanz  ·  System Architecture  ·  Group E</a:t>
-            </a:r>
-            <a:endParaRPr lang="en-US" sz="900" dirty="0"/>
-          </a:p>
-        </p:txBody>
-      </p:sp>
-      <p:sp>
-        <p:nvSpPr>
           <p:cNvPr id="7" name="Text 5"/>
           <p:cNvSpPr/>
           <p:nvPr/>
@@ -5893,45 +6481,6 @@
       </p:sp>
       <p:sp>
         <p:nvSpPr>
-          <p:cNvPr id="18" name="Text 15"/>
-          <p:cNvSpPr/>
-          <p:nvPr/>
-        </p:nvSpPr>
-        <p:spPr>
-          <a:xfrm>
-            <a:off x="2651760" y="4434840"/>
-            <a:ext cx="2331720" cy="457200"/>
-          </a:xfrm>
-          <a:prstGeom prst="rect">
-            <a:avLst/>
-          </a:prstGeom>
-          <a:noFill/>
-          <a:ln/>
-        </p:spPr>
-        <p:txBody>
-          <a:bodyPr wrap="square" lIns="0" tIns="0" rIns="0" bIns="0" rtlCol="0" anchor="ctr"/>
-          <a:lstStyle/>
-          <a:p>
-            <a:pPr marL="0" indent="0" algn="ctr">
-              <a:buNone/>
-            </a:pPr>
-            <a:r>
-              <a:rPr lang="en-US" sz="1050" i="1" dirty="0">
-                <a:solidFill>
-                  <a:srgbClr val="6E6E6C"/>
-                </a:solidFill>
-                <a:latin typeface="Arial" pitchFamily="34" charset="0"/>
-                <a:ea typeface="Arial" pitchFamily="34" charset="-122"/>
-                <a:cs typeface="Arial" pitchFamily="34" charset="-120"/>
-              </a:rPr>
-              <a:t>driving port — OperatorPanel</a:t>
-            </a:r>
-            <a:endParaRPr lang="en-US" sz="1050" dirty="0"/>
-          </a:p>
-        </p:txBody>
-      </p:sp>
-      <p:sp>
-        <p:nvSpPr>
           <p:cNvPr id="19" name="Text 16"/>
           <p:cNvSpPr/>
           <p:nvPr/>
@@ -6147,45 +6696,6 @@
               <a:t>HMI sink (MQTT)</a:t>
             </a:r>
             <a:endParaRPr lang="en-US" sz="1250" dirty="0"/>
-          </a:p>
-        </p:txBody>
-      </p:sp>
-      <p:sp>
-        <p:nvSpPr>
-          <p:cNvPr id="25" name="Text 22"/>
-          <p:cNvSpPr/>
-          <p:nvPr/>
-        </p:nvSpPr>
-        <p:spPr>
-          <a:xfrm>
-            <a:off x="7315200" y="4434840"/>
-            <a:ext cx="4206240" cy="457200"/>
-          </a:xfrm>
-          <a:prstGeom prst="rect">
-            <a:avLst/>
-          </a:prstGeom>
-          <a:noFill/>
-          <a:ln/>
-        </p:spPr>
-        <p:txBody>
-          <a:bodyPr wrap="square" lIns="0" tIns="0" rIns="0" bIns="0" rtlCol="0" anchor="ctr"/>
-          <a:lstStyle/>
-          <a:p>
-            <a:pPr marL="0" indent="0" algn="ctr">
-              <a:buNone/>
-            </a:pPr>
-            <a:r>
-              <a:rPr lang="en-US" sz="1050" i="1" dirty="0">
-                <a:solidFill>
-                  <a:srgbClr val="6E6E6C"/>
-                </a:solidFill>
-                <a:latin typeface="Arial" pitchFamily="34" charset="0"/>
-                <a:ea typeface="Arial" pitchFamily="34" charset="-122"/>
-                <a:cs typeface="Arial" pitchFamily="34" charset="-120"/>
-              </a:rPr>
-              <a:t>driven ports — PlcGateway · HmiGateway</a:t>
-            </a:r>
-            <a:endParaRPr lang="en-US" sz="1050" dirty="0"/>
           </a:p>
         </p:txBody>
       </p:sp>
@@ -6414,45 +6924,6 @@
       </p:sp>
       <p:sp>
         <p:nvSpPr>
-          <p:cNvPr id="6" name="Text 4"/>
-          <p:cNvSpPr/>
-          <p:nvPr/>
-        </p:nvSpPr>
-        <p:spPr>
-          <a:xfrm>
-            <a:off x="640080" y="6437376"/>
-            <a:ext cx="8229600" cy="274320"/>
-          </a:xfrm>
-          <a:prstGeom prst="rect">
-            <a:avLst/>
-          </a:prstGeom>
-          <a:noFill/>
-          <a:ln/>
-        </p:spPr>
-        <p:txBody>
-          <a:bodyPr wrap="square" lIns="0" tIns="0" rIns="0" bIns="0" rtlCol="0" anchor="ctr"/>
-          <a:lstStyle/>
-          <a:p>
-            <a:pPr marL="0" indent="0">
-              <a:buNone/>
-            </a:pPr>
-            <a:r>
-              <a:rPr lang="en-US" sz="900" dirty="0">
-                <a:solidFill>
-                  <a:srgbClr val="6E6E6C"/>
-                </a:solidFill>
-                <a:latin typeface="Arial" pitchFamily="34" charset="0"/>
-                <a:ea typeface="Arial" pitchFamily="34" charset="-122"/>
-                <a:cs typeface="Arial" pitchFamily="34" charset="-120"/>
-              </a:rPr>
-              <a:t>HTWG Konstanz  ·  System Architecture  ·  Group E</a:t>
-            </a:r>
-            <a:endParaRPr lang="en-US" sz="900" dirty="0"/>
-          </a:p>
-        </p:txBody>
-      </p:sp>
-      <p:sp>
-        <p:nvSpPr>
           <p:cNvPr id="7" name="Text 5"/>
           <p:cNvSpPr/>
           <p:nvPr/>
@@ -7646,45 +8117,6 @@
       </p:sp>
       <p:sp>
         <p:nvSpPr>
-          <p:cNvPr id="6" name="Text 4"/>
-          <p:cNvSpPr/>
-          <p:nvPr/>
-        </p:nvSpPr>
-        <p:spPr>
-          <a:xfrm>
-            <a:off x="640080" y="6437376"/>
-            <a:ext cx="8229600" cy="274320"/>
-          </a:xfrm>
-          <a:prstGeom prst="rect">
-            <a:avLst/>
-          </a:prstGeom>
-          <a:noFill/>
-          <a:ln/>
-        </p:spPr>
-        <p:txBody>
-          <a:bodyPr wrap="square" lIns="0" tIns="0" rIns="0" bIns="0" rtlCol="0" anchor="ctr"/>
-          <a:lstStyle/>
-          <a:p>
-            <a:pPr marL="0" indent="0">
-              <a:buNone/>
-            </a:pPr>
-            <a:r>
-              <a:rPr lang="en-US" sz="900" dirty="0">
-                <a:solidFill>
-                  <a:srgbClr val="6E6E6C"/>
-                </a:solidFill>
-                <a:latin typeface="Arial" pitchFamily="34" charset="0"/>
-                <a:ea typeface="Arial" pitchFamily="34" charset="-122"/>
-                <a:cs typeface="Arial" pitchFamily="34" charset="-120"/>
-              </a:rPr>
-              <a:t>HTWG Konstanz  ·  System Architecture  ·  Group E</a:t>
-            </a:r>
-            <a:endParaRPr lang="en-US" sz="900" dirty="0"/>
-          </a:p>
-        </p:txBody>
-      </p:sp>
-      <p:sp>
-        <p:nvSpPr>
           <p:cNvPr id="7" name="Text 5"/>
           <p:cNvSpPr/>
           <p:nvPr/>
@@ -8709,45 +9141,6 @@
       </p:sp>
       <p:sp>
         <p:nvSpPr>
-          <p:cNvPr id="6" name="Text 4"/>
-          <p:cNvSpPr/>
-          <p:nvPr/>
-        </p:nvSpPr>
-        <p:spPr>
-          <a:xfrm>
-            <a:off x="640080" y="6437376"/>
-            <a:ext cx="8229600" cy="274320"/>
-          </a:xfrm>
-          <a:prstGeom prst="rect">
-            <a:avLst/>
-          </a:prstGeom>
-          <a:noFill/>
-          <a:ln/>
-        </p:spPr>
-        <p:txBody>
-          <a:bodyPr wrap="square" lIns="0" tIns="0" rIns="0" bIns="0" rtlCol="0" anchor="ctr"/>
-          <a:lstStyle/>
-          <a:p>
-            <a:pPr marL="0" indent="0">
-              <a:buNone/>
-            </a:pPr>
-            <a:r>
-              <a:rPr lang="en-US" sz="900" dirty="0">
-                <a:solidFill>
-                  <a:srgbClr val="6E6E6C"/>
-                </a:solidFill>
-                <a:latin typeface="Arial" pitchFamily="34" charset="0"/>
-                <a:ea typeface="Arial" pitchFamily="34" charset="-122"/>
-                <a:cs typeface="Arial" pitchFamily="34" charset="-120"/>
-              </a:rPr>
-              <a:t>HTWG Konstanz  ·  System Architecture  ·  Group E</a:t>
-            </a:r>
-            <a:endParaRPr lang="en-US" sz="900" dirty="0"/>
-          </a:p>
-        </p:txBody>
-      </p:sp>
-      <p:sp>
-        <p:nvSpPr>
           <p:cNvPr id="7" name="Text 5"/>
           <p:cNvSpPr/>
           <p:nvPr/>
@@ -10114,45 +10507,6 @@
           <a:lstStyle/>
           <a:p>
             <a:endParaRPr lang="de-DE"/>
-          </a:p>
-        </p:txBody>
-      </p:sp>
-      <p:sp>
-        <p:nvSpPr>
-          <p:cNvPr id="6" name="Text 4"/>
-          <p:cNvSpPr/>
-          <p:nvPr/>
-        </p:nvSpPr>
-        <p:spPr>
-          <a:xfrm>
-            <a:off x="640080" y="6437376"/>
-            <a:ext cx="8229600" cy="274320"/>
-          </a:xfrm>
-          <a:prstGeom prst="rect">
-            <a:avLst/>
-          </a:prstGeom>
-          <a:noFill/>
-          <a:ln/>
-        </p:spPr>
-        <p:txBody>
-          <a:bodyPr wrap="square" lIns="0" tIns="0" rIns="0" bIns="0" rtlCol="0" anchor="ctr"/>
-          <a:lstStyle/>
-          <a:p>
-            <a:pPr marL="0" indent="0">
-              <a:buNone/>
-            </a:pPr>
-            <a:r>
-              <a:rPr lang="en-US" sz="900" dirty="0">
-                <a:solidFill>
-                  <a:srgbClr val="6E6E6C"/>
-                </a:solidFill>
-                <a:latin typeface="Arial" pitchFamily="34" charset="0"/>
-                <a:ea typeface="Arial" pitchFamily="34" charset="-122"/>
-                <a:cs typeface="Arial" pitchFamily="34" charset="-120"/>
-              </a:rPr>
-              <a:t>HTWG Konstanz  ·  System Architecture  ·  Group E</a:t>
-            </a:r>
-            <a:endParaRPr lang="en-US" sz="900" dirty="0"/>
           </a:p>
         </p:txBody>
       </p:sp>
@@ -11973,45 +12327,6 @@
       </p:sp>
       <p:sp>
         <p:nvSpPr>
-          <p:cNvPr id="6" name="Text 4"/>
-          <p:cNvSpPr/>
-          <p:nvPr/>
-        </p:nvSpPr>
-        <p:spPr>
-          <a:xfrm>
-            <a:off x="640080" y="6437376"/>
-            <a:ext cx="8229600" cy="274320"/>
-          </a:xfrm>
-          <a:prstGeom prst="rect">
-            <a:avLst/>
-          </a:prstGeom>
-          <a:noFill/>
-          <a:ln/>
-        </p:spPr>
-        <p:txBody>
-          <a:bodyPr wrap="square" lIns="0" tIns="0" rIns="0" bIns="0" rtlCol="0" anchor="ctr"/>
-          <a:lstStyle/>
-          <a:p>
-            <a:pPr marL="0" indent="0">
-              <a:buNone/>
-            </a:pPr>
-            <a:r>
-              <a:rPr lang="en-US" sz="900" dirty="0">
-                <a:solidFill>
-                  <a:srgbClr val="6E6E6C"/>
-                </a:solidFill>
-                <a:latin typeface="Arial" pitchFamily="34" charset="0"/>
-                <a:ea typeface="Arial" pitchFamily="34" charset="-122"/>
-                <a:cs typeface="Arial" pitchFamily="34" charset="-120"/>
-              </a:rPr>
-              <a:t>HTWG Konstanz  ·  System Architecture  ·  Group E</a:t>
-            </a:r>
-            <a:endParaRPr lang="en-US" sz="900" dirty="0"/>
-          </a:p>
-        </p:txBody>
-      </p:sp>
-      <p:sp>
-        <p:nvSpPr>
           <p:cNvPr id="7" name="Text 5"/>
           <p:cNvSpPr/>
           <p:nvPr/>
@@ -13911,45 +14226,6 @@
       </p:sp>
       <p:sp>
         <p:nvSpPr>
-          <p:cNvPr id="6" name="Text 4"/>
-          <p:cNvSpPr/>
-          <p:nvPr/>
-        </p:nvSpPr>
-        <p:spPr>
-          <a:xfrm>
-            <a:off x="640080" y="6437376"/>
-            <a:ext cx="8229600" cy="274320"/>
-          </a:xfrm>
-          <a:prstGeom prst="rect">
-            <a:avLst/>
-          </a:prstGeom>
-          <a:noFill/>
-          <a:ln/>
-        </p:spPr>
-        <p:txBody>
-          <a:bodyPr wrap="square" lIns="0" tIns="0" rIns="0" bIns="0" rtlCol="0" anchor="ctr"/>
-          <a:lstStyle/>
-          <a:p>
-            <a:pPr marL="0" indent="0">
-              <a:buNone/>
-            </a:pPr>
-            <a:r>
-              <a:rPr lang="en-US" sz="900" dirty="0">
-                <a:solidFill>
-                  <a:srgbClr val="6E6E6C"/>
-                </a:solidFill>
-                <a:latin typeface="Arial" pitchFamily="34" charset="0"/>
-                <a:ea typeface="Arial" pitchFamily="34" charset="-122"/>
-                <a:cs typeface="Arial" pitchFamily="34" charset="-120"/>
-              </a:rPr>
-              <a:t>HTWG Konstanz  ·  System Architecture  ·  Group E</a:t>
-            </a:r>
-            <a:endParaRPr lang="en-US" sz="900" dirty="0"/>
-          </a:p>
-        </p:txBody>
-      </p:sp>
-      <p:sp>
-        <p:nvSpPr>
           <p:cNvPr id="7" name="Text 5"/>
           <p:cNvSpPr/>
           <p:nvPr/>
@@ -14827,13 +15103,208 @@
       </p:sp>
       <p:sp>
         <p:nvSpPr>
-          <p:cNvPr id="5" name="Shape 3"/>
-          <p:cNvSpPr/>
-          <p:nvPr/>
-        </p:nvSpPr>
-        <p:spPr>
-          <a:xfrm>
-            <a:off x="640080" y="6382512"/>
+          <p:cNvPr id="7" name="Text 5"/>
+          <p:cNvSpPr/>
+          <p:nvPr/>
+        </p:nvSpPr>
+        <p:spPr>
+          <a:xfrm>
+            <a:off x="10881360" y="6437376"/>
+            <a:ext cx="667512" cy="274320"/>
+          </a:xfrm>
+          <a:prstGeom prst="rect">
+            <a:avLst/>
+          </a:prstGeom>
+          <a:noFill/>
+          <a:ln/>
+        </p:spPr>
+        <p:txBody>
+          <a:bodyPr wrap="square" lIns="0" tIns="0" rIns="0" bIns="0" rtlCol="0" anchor="ctr"/>
+          <a:lstStyle/>
+          <a:p>
+            <a:pPr marL="0" indent="0" algn="r">
+              <a:buNone/>
+            </a:pPr>
+            <a:r>
+              <a:rPr lang="en-US" sz="900" dirty="0">
+                <a:solidFill>
+                  <a:srgbClr val="6E6E6C"/>
+                </a:solidFill>
+                <a:latin typeface="Arial" pitchFamily="34" charset="0"/>
+                <a:ea typeface="Arial" pitchFamily="34" charset="-122"/>
+                <a:cs typeface="Arial" pitchFamily="34" charset="-120"/>
+              </a:rPr>
+              <a:t>1</a:t>
+            </a:r>
+            <a:endParaRPr lang="en-US" sz="900" dirty="0"/>
+          </a:p>
+        </p:txBody>
+      </p:sp>
+      <p:sp>
+        <p:nvSpPr>
+          <p:cNvPr id="9" name="Text 6"/>
+          <p:cNvSpPr/>
+          <p:nvPr/>
+        </p:nvSpPr>
+        <p:spPr>
+          <a:xfrm>
+            <a:off x="640080" y="2084832"/>
+            <a:ext cx="1280160" cy="457200"/>
+          </a:xfrm>
+          <a:prstGeom prst="rect">
+            <a:avLst/>
+          </a:prstGeom>
+          <a:noFill/>
+          <a:ln/>
+        </p:spPr>
+        <p:txBody>
+          <a:bodyPr wrap="square" lIns="0" tIns="0" rIns="0" bIns="0" rtlCol="0" anchor="t"/>
+          <a:lstStyle/>
+          <a:p>
+            <a:pPr marL="0" indent="0">
+              <a:buNone/>
+            </a:pPr>
+            <a:r>
+              <a:rPr lang="en-US" sz="1500" b="1" dirty="0">
+                <a:solidFill>
+                  <a:srgbClr val="0B6E7A"/>
+                </a:solidFill>
+                <a:latin typeface="Arial" pitchFamily="34" charset="0"/>
+                <a:ea typeface="Arial" pitchFamily="34" charset="-122"/>
+                <a:cs typeface="Arial" pitchFamily="34" charset="-120"/>
+              </a:rPr>
+              <a:t>Part 1</a:t>
+            </a:r>
+            <a:endParaRPr lang="en-US" sz="1500" dirty="0"/>
+          </a:p>
+        </p:txBody>
+      </p:sp>
+      <p:sp>
+        <p:nvSpPr>
+          <p:cNvPr id="10" name="Text 7"/>
+          <p:cNvSpPr/>
+          <p:nvPr/>
+        </p:nvSpPr>
+        <p:spPr>
+          <a:xfrm>
+            <a:off x="1554480" y="1947672"/>
+            <a:ext cx="7315200" cy="502920"/>
+          </a:xfrm>
+          <a:prstGeom prst="rect">
+            <a:avLst/>
+          </a:prstGeom>
+          <a:noFill/>
+          <a:ln/>
+        </p:spPr>
+        <p:txBody>
+          <a:bodyPr wrap="square" lIns="0" tIns="0" rIns="0" bIns="0" rtlCol="0" anchor="ctr"/>
+          <a:lstStyle/>
+          <a:p>
+            <a:pPr marL="0" indent="0">
+              <a:buNone/>
+            </a:pPr>
+            <a:r>
+              <a:rPr lang="en-US" sz="2200" b="1" dirty="0">
+                <a:solidFill>
+                  <a:srgbClr val="2D2D2B"/>
+                </a:solidFill>
+                <a:latin typeface="Arial" pitchFamily="34" charset="0"/>
+                <a:ea typeface="Arial" pitchFamily="34" charset="-122"/>
+                <a:cs typeface="Arial" pitchFamily="34" charset="-120"/>
+              </a:rPr>
+              <a:t>The HMI &amp; Operator Interface</a:t>
+            </a:r>
+            <a:endParaRPr lang="en-US" sz="2200" dirty="0"/>
+          </a:p>
+        </p:txBody>
+      </p:sp>
+      <p:sp>
+        <p:nvSpPr>
+          <p:cNvPr id="11" name="Text 8"/>
+          <p:cNvSpPr/>
+          <p:nvPr/>
+        </p:nvSpPr>
+        <p:spPr>
+          <a:xfrm>
+            <a:off x="1554480" y="2189988"/>
+            <a:ext cx="7863840" cy="548640"/>
+          </a:xfrm>
+          <a:prstGeom prst="rect">
+            <a:avLst/>
+          </a:prstGeom>
+          <a:noFill/>
+          <a:ln/>
+        </p:spPr>
+        <p:txBody>
+          <a:bodyPr wrap="square" lIns="0" tIns="0" rIns="0" bIns="0" rtlCol="0" anchor="ctr"/>
+          <a:lstStyle/>
+          <a:p>
+            <a:pPr marL="0" indent="0">
+              <a:buNone/>
+            </a:pPr>
+            <a:r>
+              <a:rPr lang="en-US" sz="1400" dirty="0">
+                <a:solidFill>
+                  <a:srgbClr val="6E6E6C"/>
+                </a:solidFill>
+                <a:latin typeface="Arial" pitchFamily="34" charset="0"/>
+                <a:ea typeface="Arial" pitchFamily="34" charset="-122"/>
+                <a:cs typeface="Arial" pitchFamily="34" charset="-120"/>
+              </a:rPr>
+              <a:t>What the operator sees, the MQTT interface, the status payload, the HMI app.</a:t>
+            </a:r>
+            <a:endParaRPr lang="en-US" sz="1400" dirty="0"/>
+          </a:p>
+        </p:txBody>
+      </p:sp>
+      <p:sp>
+        <p:nvSpPr>
+          <p:cNvPr id="12" name="Text 9"/>
+          <p:cNvSpPr/>
+          <p:nvPr/>
+        </p:nvSpPr>
+        <p:spPr>
+          <a:xfrm>
+            <a:off x="8326215" y="2133703"/>
+            <a:ext cx="1861580" cy="921815"/>
+          </a:xfrm>
+          <a:prstGeom prst="rect">
+            <a:avLst/>
+          </a:prstGeom>
+          <a:noFill/>
+          <a:ln/>
+        </p:spPr>
+        <p:txBody>
+          <a:bodyPr wrap="square" lIns="0" tIns="0" rIns="0" bIns="0" rtlCol="0" anchor="t"/>
+          <a:lstStyle/>
+          <a:p>
+            <a:pPr marL="0" indent="0" algn="r">
+              <a:buNone/>
+            </a:pPr>
+            <a:r>
+              <a:rPr lang="en-US" sz="1500" b="1" dirty="0">
+                <a:solidFill>
+                  <a:srgbClr val="2D2D2B"/>
+                </a:solidFill>
+                <a:latin typeface="Arial" pitchFamily="34" charset="0"/>
+                <a:ea typeface="Arial" pitchFamily="34" charset="-122"/>
+                <a:cs typeface="Arial" pitchFamily="34" charset="-120"/>
+              </a:rPr>
+              <a:t>Yasin &amp; Mevlüt</a:t>
+            </a:r>
+            <a:endParaRPr lang="en-US" sz="1500" dirty="0"/>
+          </a:p>
+        </p:txBody>
+      </p:sp>
+      <p:sp>
+        <p:nvSpPr>
+          <p:cNvPr id="13" name="Shape 10"/>
+          <p:cNvSpPr/>
+          <p:nvPr/>
+        </p:nvSpPr>
+        <p:spPr>
+          <a:xfrm>
+            <a:off x="640080" y="3383280"/>
             <a:ext cx="10908792" cy="0"/>
           </a:xfrm>
           <a:prstGeom prst="line">
@@ -14857,14 +15328,53 @@
       </p:sp>
       <p:sp>
         <p:nvSpPr>
-          <p:cNvPr id="6" name="Text 4"/>
-          <p:cNvSpPr/>
-          <p:nvPr/>
-        </p:nvSpPr>
-        <p:spPr>
-          <a:xfrm>
-            <a:off x="640080" y="6437376"/>
-            <a:ext cx="8229600" cy="274320"/>
+          <p:cNvPr id="14" name="Text 11"/>
+          <p:cNvSpPr/>
+          <p:nvPr/>
+        </p:nvSpPr>
+        <p:spPr>
+          <a:xfrm>
+            <a:off x="640080" y="3776472"/>
+            <a:ext cx="1280160" cy="457200"/>
+          </a:xfrm>
+          <a:prstGeom prst="rect">
+            <a:avLst/>
+          </a:prstGeom>
+          <a:noFill/>
+          <a:ln/>
+        </p:spPr>
+        <p:txBody>
+          <a:bodyPr wrap="square" lIns="0" tIns="0" rIns="0" bIns="0" rtlCol="0" anchor="t"/>
+          <a:lstStyle/>
+          <a:p>
+            <a:pPr marL="0" indent="0">
+              <a:buNone/>
+            </a:pPr>
+            <a:r>
+              <a:rPr lang="en-US" sz="1500" b="1" dirty="0">
+                <a:solidFill>
+                  <a:srgbClr val="0B6E7A"/>
+                </a:solidFill>
+                <a:latin typeface="Arial" pitchFamily="34" charset="0"/>
+                <a:ea typeface="Arial" pitchFamily="34" charset="-122"/>
+                <a:cs typeface="Arial" pitchFamily="34" charset="-120"/>
+              </a:rPr>
+              <a:t>Part 2</a:t>
+            </a:r>
+            <a:endParaRPr lang="en-US" sz="1500" dirty="0"/>
+          </a:p>
+        </p:txBody>
+      </p:sp>
+      <p:sp>
+        <p:nvSpPr>
+          <p:cNvPr id="15" name="Text 12"/>
+          <p:cNvSpPr/>
+          <p:nvPr/>
+        </p:nvSpPr>
+        <p:spPr>
+          <a:xfrm>
+            <a:off x="1554480" y="3607308"/>
+            <a:ext cx="7315200" cy="502920"/>
           </a:xfrm>
           <a:prstGeom prst="rect">
             <a:avLst/>
@@ -14880,7 +15390,46 @@
               <a:buNone/>
             </a:pPr>
             <a:r>
-              <a:rPr lang="en-US" sz="900" dirty="0">
+              <a:rPr lang="en-US" sz="2200" b="1" dirty="0">
+                <a:solidFill>
+                  <a:srgbClr val="2D2D2B"/>
+                </a:solidFill>
+                <a:latin typeface="Arial" pitchFamily="34" charset="0"/>
+                <a:ea typeface="Arial" pitchFamily="34" charset="-122"/>
+                <a:cs typeface="Arial" pitchFamily="34" charset="-120"/>
+              </a:rPr>
+              <a:t>The Control System</a:t>
+            </a:r>
+            <a:endParaRPr lang="en-US" sz="2200" dirty="0"/>
+          </a:p>
+        </p:txBody>
+      </p:sp>
+      <p:sp>
+        <p:nvSpPr>
+          <p:cNvPr id="16" name="Text 13"/>
+          <p:cNvSpPr/>
+          <p:nvPr/>
+        </p:nvSpPr>
+        <p:spPr>
+          <a:xfrm>
+            <a:off x="1554480" y="3873174"/>
+            <a:ext cx="7863840" cy="548640"/>
+          </a:xfrm>
+          <a:prstGeom prst="rect">
+            <a:avLst/>
+          </a:prstGeom>
+          <a:noFill/>
+          <a:ln/>
+        </p:spPr>
+        <p:txBody>
+          <a:bodyPr wrap="square" lIns="0" tIns="0" rIns="0" bIns="0" rtlCol="0" anchor="ctr"/>
+          <a:lstStyle/>
+          <a:p>
+            <a:pPr marL="0" indent="0">
+              <a:buNone/>
+            </a:pPr>
+            <a:r>
+              <a:rPr lang="en-US" sz="1400" dirty="0">
                 <a:solidFill>
                   <a:srgbClr val="6E6E6C"/>
                 </a:solidFill>
@@ -14888,85 +15437,46 @@
                 <a:ea typeface="Arial" pitchFamily="34" charset="-122"/>
                 <a:cs typeface="Arial" pitchFamily="34" charset="-120"/>
               </a:rPr>
-              <a:t>HTWG Konstanz  ·  System Architecture  ·  Group E</a:t>
-            </a:r>
-            <a:endParaRPr lang="en-US" sz="900" dirty="0"/>
-          </a:p>
-        </p:txBody>
-      </p:sp>
-      <p:sp>
-        <p:nvSpPr>
-          <p:cNvPr id="7" name="Text 5"/>
-          <p:cNvSpPr/>
-          <p:nvPr/>
-        </p:nvSpPr>
-        <p:spPr>
-          <a:xfrm>
-            <a:off x="10881360" y="6437376"/>
-            <a:ext cx="667512" cy="274320"/>
-          </a:xfrm>
-          <a:prstGeom prst="rect">
-            <a:avLst/>
-          </a:prstGeom>
-          <a:noFill/>
-          <a:ln/>
-        </p:spPr>
-        <p:txBody>
-          <a:bodyPr wrap="square" lIns="0" tIns="0" rIns="0" bIns="0" rtlCol="0" anchor="ctr"/>
+              <a:t>Requirements, hexagonal architecture, the SCAN logic, I/O, deployment &amp; live demo.</a:t>
+            </a:r>
+            <a:endParaRPr lang="en-US" sz="1400" dirty="0"/>
+          </a:p>
+        </p:txBody>
+      </p:sp>
+      <p:sp>
+        <p:nvSpPr>
+          <p:cNvPr id="17" name="Text 14"/>
+          <p:cNvSpPr/>
+          <p:nvPr/>
+        </p:nvSpPr>
+        <p:spPr>
+          <a:xfrm>
+            <a:off x="8608299" y="3774316"/>
+            <a:ext cx="1724420" cy="822960"/>
+          </a:xfrm>
+          <a:prstGeom prst="rect">
+            <a:avLst/>
+          </a:prstGeom>
+          <a:noFill/>
+          <a:ln/>
+        </p:spPr>
+        <p:txBody>
+          <a:bodyPr wrap="square" lIns="0" tIns="0" rIns="0" bIns="0" rtlCol="0" anchor="t"/>
           <a:lstStyle/>
           <a:p>
             <a:pPr marL="0" indent="0" algn="r">
               <a:buNone/>
             </a:pPr>
             <a:r>
-              <a:rPr lang="en-US" sz="900" dirty="0">
-                <a:solidFill>
-                  <a:srgbClr val="6E6E6C"/>
-                </a:solidFill>
-                <a:latin typeface="Arial" pitchFamily="34" charset="0"/>
-                <a:ea typeface="Arial" pitchFamily="34" charset="-122"/>
-                <a:cs typeface="Arial" pitchFamily="34" charset="-120"/>
-              </a:rPr>
-              <a:t>1</a:t>
-            </a:r>
-            <a:endParaRPr lang="en-US" sz="900" dirty="0"/>
-          </a:p>
-        </p:txBody>
-      </p:sp>
-      <p:sp>
-        <p:nvSpPr>
-          <p:cNvPr id="9" name="Text 6"/>
-          <p:cNvSpPr/>
-          <p:nvPr/>
-        </p:nvSpPr>
-        <p:spPr>
-          <a:xfrm>
-            <a:off x="640080" y="2084832"/>
-            <a:ext cx="1280160" cy="457200"/>
-          </a:xfrm>
-          <a:prstGeom prst="rect">
-            <a:avLst/>
-          </a:prstGeom>
-          <a:noFill/>
-          <a:ln/>
-        </p:spPr>
-        <p:txBody>
-          <a:bodyPr wrap="square" lIns="0" tIns="0" rIns="0" bIns="0" rtlCol="0" anchor="t"/>
-          <a:lstStyle/>
-          <a:p>
-            <a:pPr marL="0" indent="0">
-              <a:buNone/>
-            </a:pPr>
-            <a:r>
               <a:rPr lang="en-US" sz="1500" b="1" dirty="0">
                 <a:solidFill>
-                  <a:srgbClr val="0B6E7A"/>
-                </a:solidFill>
-                <a:latin typeface="Arial" pitchFamily="34" charset="0"/>
-                <a:ea typeface="Arial" pitchFamily="34" charset="-122"/>
-                <a:cs typeface="Arial" pitchFamily="34" charset="-120"/>
-              </a:rPr>
-              <a:t>Part 1</a:t>
+                  <a:srgbClr val="2D2D2B"/>
+                </a:solidFill>
+                <a:latin typeface="Arial" pitchFamily="34" charset="0"/>
+                <a:ea typeface="Arial" pitchFamily="34" charset="-122"/>
+                <a:cs typeface="Arial" pitchFamily="34" charset="-120"/>
+              </a:rPr>
+              <a:t>Ruben &amp; Lukas</a:t>
             </a:r>
             <a:endParaRPr lang="en-US" sz="1500" dirty="0"/>
           </a:p>
@@ -14974,130 +15484,13 @@
       </p:sp>
       <p:sp>
         <p:nvSpPr>
-          <p:cNvPr id="10" name="Text 7"/>
-          <p:cNvSpPr/>
-          <p:nvPr/>
-        </p:nvSpPr>
-        <p:spPr>
-          <a:xfrm>
-            <a:off x="1965960" y="2057400"/>
-            <a:ext cx="7315200" cy="502920"/>
-          </a:xfrm>
-          <a:prstGeom prst="rect">
-            <a:avLst/>
-          </a:prstGeom>
-          <a:noFill/>
-          <a:ln/>
-        </p:spPr>
-        <p:txBody>
-          <a:bodyPr wrap="square" lIns="0" tIns="0" rIns="0" bIns="0" rtlCol="0" anchor="ctr"/>
-          <a:lstStyle/>
-          <a:p>
-            <a:pPr marL="0" indent="0">
-              <a:buNone/>
-            </a:pPr>
-            <a:r>
-              <a:rPr lang="en-US" sz="2200" b="1" dirty="0">
-                <a:solidFill>
-                  <a:srgbClr val="2D2D2B"/>
-                </a:solidFill>
-                <a:latin typeface="Arial" pitchFamily="34" charset="0"/>
-                <a:ea typeface="Arial" pitchFamily="34" charset="-122"/>
-                <a:cs typeface="Arial" pitchFamily="34" charset="-120"/>
-              </a:rPr>
-              <a:t>The HMI &amp; Operator Interface</a:t>
-            </a:r>
-            <a:endParaRPr lang="en-US" sz="2200" dirty="0"/>
-          </a:p>
-        </p:txBody>
-      </p:sp>
-      <p:sp>
-        <p:nvSpPr>
-          <p:cNvPr id="11" name="Text 8"/>
-          <p:cNvSpPr/>
-          <p:nvPr/>
-        </p:nvSpPr>
-        <p:spPr>
-          <a:xfrm>
-            <a:off x="1965960" y="2578608"/>
-            <a:ext cx="7863840" cy="548640"/>
-          </a:xfrm>
-          <a:prstGeom prst="rect">
-            <a:avLst/>
-          </a:prstGeom>
-          <a:noFill/>
-          <a:ln/>
-        </p:spPr>
-        <p:txBody>
-          <a:bodyPr wrap="square" lIns="0" tIns="0" rIns="0" bIns="0" rtlCol="0" anchor="ctr"/>
-          <a:lstStyle/>
-          <a:p>
-            <a:pPr marL="0" indent="0">
-              <a:buNone/>
-            </a:pPr>
-            <a:r>
-              <a:rPr lang="en-US" sz="1400" dirty="0">
-                <a:solidFill>
-                  <a:srgbClr val="6E6E6C"/>
-                </a:solidFill>
-                <a:latin typeface="Arial" pitchFamily="34" charset="0"/>
-                <a:ea typeface="Arial" pitchFamily="34" charset="-122"/>
-                <a:cs typeface="Arial" pitchFamily="34" charset="-120"/>
-              </a:rPr>
-              <a:t>What the operator sees, the MQTT interface, the status payload, the HMI app.</a:t>
-            </a:r>
-            <a:endParaRPr lang="en-US" sz="1400" dirty="0"/>
-          </a:p>
-        </p:txBody>
-      </p:sp>
-      <p:sp>
-        <p:nvSpPr>
-          <p:cNvPr id="12" name="Text 9"/>
-          <p:cNvSpPr/>
-          <p:nvPr/>
-        </p:nvSpPr>
-        <p:spPr>
-          <a:xfrm>
-            <a:off x="9418320" y="2057400"/>
-            <a:ext cx="2103120" cy="822960"/>
-          </a:xfrm>
-          <a:prstGeom prst="rect">
-            <a:avLst/>
-          </a:prstGeom>
-          <a:noFill/>
-          <a:ln/>
-        </p:spPr>
-        <p:txBody>
-          <a:bodyPr wrap="square" lIns="0" tIns="0" rIns="0" bIns="0" rtlCol="0" anchor="t"/>
-          <a:lstStyle/>
-          <a:p>
-            <a:pPr marL="0" indent="0" algn="r">
-              <a:buNone/>
-            </a:pPr>
-            <a:r>
-              <a:rPr lang="en-US" sz="1500" b="1" dirty="0">
-                <a:solidFill>
-                  <a:srgbClr val="2D2D2B"/>
-                </a:solidFill>
-                <a:latin typeface="Arial" pitchFamily="34" charset="0"/>
-                <a:ea typeface="Arial" pitchFamily="34" charset="-122"/>
-                <a:cs typeface="Arial" pitchFamily="34" charset="-120"/>
-              </a:rPr>
-              <a:t>Yasin &amp; Mevlüt</a:t>
-            </a:r>
-            <a:endParaRPr lang="en-US" sz="1500" dirty="0"/>
-          </a:p>
-        </p:txBody>
-      </p:sp>
-      <p:sp>
-        <p:nvSpPr>
-          <p:cNvPr id="13" name="Shape 10"/>
-          <p:cNvSpPr/>
-          <p:nvPr/>
-        </p:nvSpPr>
-        <p:spPr>
-          <a:xfrm>
-            <a:off x="640080" y="3383280"/>
+          <p:cNvPr id="18" name="Shape 15"/>
+          <p:cNvSpPr/>
+          <p:nvPr/>
+        </p:nvSpPr>
+        <p:spPr>
+          <a:xfrm>
+            <a:off x="640080" y="5074920"/>
             <a:ext cx="10908792" cy="0"/>
           </a:xfrm>
           <a:prstGeom prst="line">
@@ -15121,199 +15514,13 @@
       </p:sp>
       <p:sp>
         <p:nvSpPr>
-          <p:cNvPr id="14" name="Text 11"/>
-          <p:cNvSpPr/>
-          <p:nvPr/>
-        </p:nvSpPr>
-        <p:spPr>
-          <a:xfrm>
-            <a:off x="640080" y="3776472"/>
-            <a:ext cx="1280160" cy="457200"/>
-          </a:xfrm>
-          <a:prstGeom prst="rect">
-            <a:avLst/>
-          </a:prstGeom>
-          <a:noFill/>
-          <a:ln/>
-        </p:spPr>
-        <p:txBody>
-          <a:bodyPr wrap="square" lIns="0" tIns="0" rIns="0" bIns="0" rtlCol="0" anchor="t"/>
-          <a:lstStyle/>
-          <a:p>
-            <a:pPr marL="0" indent="0">
-              <a:buNone/>
-            </a:pPr>
-            <a:r>
-              <a:rPr lang="en-US" sz="1500" b="1" dirty="0">
-                <a:solidFill>
-                  <a:srgbClr val="0B6E7A"/>
-                </a:solidFill>
-                <a:latin typeface="Arial" pitchFamily="34" charset="0"/>
-                <a:ea typeface="Arial" pitchFamily="34" charset="-122"/>
-                <a:cs typeface="Arial" pitchFamily="34" charset="-120"/>
-              </a:rPr>
-              <a:t>Part 2</a:t>
-            </a:r>
-            <a:endParaRPr lang="en-US" sz="1500" dirty="0"/>
-          </a:p>
-        </p:txBody>
-      </p:sp>
-      <p:sp>
-        <p:nvSpPr>
-          <p:cNvPr id="15" name="Text 12"/>
-          <p:cNvSpPr/>
-          <p:nvPr/>
-        </p:nvSpPr>
-        <p:spPr>
-          <a:xfrm>
-            <a:off x="1965960" y="3749040"/>
-            <a:ext cx="7315200" cy="502920"/>
-          </a:xfrm>
-          <a:prstGeom prst="rect">
-            <a:avLst/>
-          </a:prstGeom>
-          <a:noFill/>
-          <a:ln/>
-        </p:spPr>
-        <p:txBody>
-          <a:bodyPr wrap="square" lIns="0" tIns="0" rIns="0" bIns="0" rtlCol="0" anchor="ctr"/>
-          <a:lstStyle/>
-          <a:p>
-            <a:pPr marL="0" indent="0">
-              <a:buNone/>
-            </a:pPr>
-            <a:r>
-              <a:rPr lang="en-US" sz="2200" b="1" dirty="0">
-                <a:solidFill>
-                  <a:srgbClr val="2D2D2B"/>
-                </a:solidFill>
-                <a:latin typeface="Arial" pitchFamily="34" charset="0"/>
-                <a:ea typeface="Arial" pitchFamily="34" charset="-122"/>
-                <a:cs typeface="Arial" pitchFamily="34" charset="-120"/>
-              </a:rPr>
-              <a:t>The Control System</a:t>
-            </a:r>
-            <a:endParaRPr lang="en-US" sz="2200" dirty="0"/>
-          </a:p>
-        </p:txBody>
-      </p:sp>
-      <p:sp>
-        <p:nvSpPr>
-          <p:cNvPr id="16" name="Text 13"/>
-          <p:cNvSpPr/>
-          <p:nvPr/>
-        </p:nvSpPr>
-        <p:spPr>
-          <a:xfrm>
-            <a:off x="1965960" y="4270248"/>
-            <a:ext cx="7863840" cy="548640"/>
-          </a:xfrm>
-          <a:prstGeom prst="rect">
-            <a:avLst/>
-          </a:prstGeom>
-          <a:noFill/>
-          <a:ln/>
-        </p:spPr>
-        <p:txBody>
-          <a:bodyPr wrap="square" lIns="0" tIns="0" rIns="0" bIns="0" rtlCol="0" anchor="ctr"/>
-          <a:lstStyle/>
-          <a:p>
-            <a:pPr marL="0" indent="0">
-              <a:buNone/>
-            </a:pPr>
-            <a:r>
-              <a:rPr lang="en-US" sz="1400" dirty="0">
-                <a:solidFill>
-                  <a:srgbClr val="6E6E6C"/>
-                </a:solidFill>
-                <a:latin typeface="Arial" pitchFamily="34" charset="0"/>
-                <a:ea typeface="Arial" pitchFamily="34" charset="-122"/>
-                <a:cs typeface="Arial" pitchFamily="34" charset="-120"/>
-              </a:rPr>
-              <a:t>Requirements, hexagonal architecture, the SCAN logic, I/O, deployment &amp; live demo.</a:t>
-            </a:r>
-            <a:endParaRPr lang="en-US" sz="1400" dirty="0"/>
-          </a:p>
-        </p:txBody>
-      </p:sp>
-      <p:sp>
-        <p:nvSpPr>
-          <p:cNvPr id="17" name="Text 14"/>
-          <p:cNvSpPr/>
-          <p:nvPr/>
-        </p:nvSpPr>
-        <p:spPr>
-          <a:xfrm>
-            <a:off x="9418320" y="3749040"/>
-            <a:ext cx="2103120" cy="822960"/>
-          </a:xfrm>
-          <a:prstGeom prst="rect">
-            <a:avLst/>
-          </a:prstGeom>
-          <a:noFill/>
-          <a:ln/>
-        </p:spPr>
-        <p:txBody>
-          <a:bodyPr wrap="square" lIns="0" tIns="0" rIns="0" bIns="0" rtlCol="0" anchor="t"/>
-          <a:lstStyle/>
-          <a:p>
-            <a:pPr marL="0" indent="0" algn="r">
-              <a:buNone/>
-            </a:pPr>
-            <a:r>
-              <a:rPr lang="en-US" sz="1500" b="1" dirty="0">
-                <a:solidFill>
-                  <a:srgbClr val="2D2D2B"/>
-                </a:solidFill>
-                <a:latin typeface="Arial" pitchFamily="34" charset="0"/>
-                <a:ea typeface="Arial" pitchFamily="34" charset="-122"/>
-                <a:cs typeface="Arial" pitchFamily="34" charset="-120"/>
-              </a:rPr>
-              <a:t>Ruben &amp; Lukas</a:t>
-            </a:r>
-            <a:endParaRPr lang="en-US" sz="1500" dirty="0"/>
-          </a:p>
-        </p:txBody>
-      </p:sp>
-      <p:sp>
-        <p:nvSpPr>
-          <p:cNvPr id="18" name="Shape 15"/>
-          <p:cNvSpPr/>
-          <p:nvPr/>
-        </p:nvSpPr>
-        <p:spPr>
-          <a:xfrm>
-            <a:off x="640080" y="5074920"/>
-            <a:ext cx="10908792" cy="0"/>
-          </a:xfrm>
-          <a:prstGeom prst="line">
-            <a:avLst/>
-          </a:prstGeom>
-          <a:noFill/>
-          <a:ln w="9525">
-            <a:solidFill>
-              <a:srgbClr val="D7D7D5"/>
-            </a:solidFill>
-            <a:prstDash val="solid"/>
-          </a:ln>
-        </p:spPr>
-        <p:txBody>
-          <a:bodyPr/>
-          <a:lstStyle/>
-          <a:p>
-            <a:endParaRPr lang="de-DE"/>
-          </a:p>
-        </p:txBody>
-      </p:sp>
-      <p:sp>
-        <p:nvSpPr>
           <p:cNvPr id="19" name="Text 16"/>
           <p:cNvSpPr/>
           <p:nvPr/>
         </p:nvSpPr>
         <p:spPr>
           <a:xfrm>
-            <a:off x="640080" y="5669280"/>
+            <a:off x="640080" y="5186805"/>
             <a:ext cx="10972800" cy="365760"/>
           </a:xfrm>
           <a:prstGeom prst="rect">
@@ -15487,45 +15694,6 @@
       </p:sp>
       <p:sp>
         <p:nvSpPr>
-          <p:cNvPr id="6" name="Text 4"/>
-          <p:cNvSpPr/>
-          <p:nvPr/>
-        </p:nvSpPr>
-        <p:spPr>
-          <a:xfrm>
-            <a:off x="640080" y="6437376"/>
-            <a:ext cx="8229600" cy="274320"/>
-          </a:xfrm>
-          <a:prstGeom prst="rect">
-            <a:avLst/>
-          </a:prstGeom>
-          <a:noFill/>
-          <a:ln/>
-        </p:spPr>
-        <p:txBody>
-          <a:bodyPr wrap="square" lIns="0" tIns="0" rIns="0" bIns="0" rtlCol="0" anchor="ctr"/>
-          <a:lstStyle/>
-          <a:p>
-            <a:pPr marL="0" indent="0">
-              <a:buNone/>
-            </a:pPr>
-            <a:r>
-              <a:rPr lang="en-US" sz="900" dirty="0">
-                <a:solidFill>
-                  <a:srgbClr val="6E6E6C"/>
-                </a:solidFill>
-                <a:latin typeface="Arial" pitchFamily="34" charset="0"/>
-                <a:ea typeface="Arial" pitchFamily="34" charset="-122"/>
-                <a:cs typeface="Arial" pitchFamily="34" charset="-120"/>
-              </a:rPr>
-              <a:t>HTWG Konstanz  ·  System Architecture  ·  Group E</a:t>
-            </a:r>
-            <a:endParaRPr lang="en-US" sz="900" dirty="0"/>
-          </a:p>
-        </p:txBody>
-      </p:sp>
-      <p:sp>
-        <p:nvSpPr>
           <p:cNvPr id="7" name="Text 5"/>
           <p:cNvSpPr/>
           <p:nvPr/>
@@ -16184,7 +16352,7 @@
         </p:nvSpPr>
         <p:spPr>
           <a:xfrm>
-            <a:off x="841248" y="3703320"/>
+            <a:off x="841248" y="3291840"/>
             <a:ext cx="9875520" cy="822960"/>
           </a:xfrm>
           <a:prstGeom prst="rect">
@@ -16212,56 +16380,6 @@
               <a:t>What the operator sees, the MQTT interface it speaks, and the status it reads.</a:t>
             </a:r>
             <a:endParaRPr lang="en-US" sz="1700" dirty="0"/>
-          </a:p>
-        </p:txBody>
-      </p:sp>
-      <p:sp>
-        <p:nvSpPr>
-          <p:cNvPr id="6" name="Text 4"/>
-          <p:cNvSpPr/>
-          <p:nvPr/>
-        </p:nvSpPr>
-        <p:spPr>
-          <a:xfrm>
-            <a:off x="841248" y="4800600"/>
-            <a:ext cx="8229600" cy="365760"/>
-          </a:xfrm>
-          <a:prstGeom prst="rect">
-            <a:avLst/>
-          </a:prstGeom>
-          <a:noFill/>
-          <a:ln/>
-        </p:spPr>
-        <p:txBody>
-          <a:bodyPr wrap="square" lIns="0" tIns="0" rIns="0" bIns="0" rtlCol="0" anchor="ctr"/>
-          <a:lstStyle/>
-          <a:p>
-            <a:pPr marL="0" indent="0">
-              <a:buNone/>
-            </a:pPr>
-            <a:r>
-              <a:rPr lang="en-US" sz="1500" dirty="0">
-                <a:solidFill>
-                  <a:srgbClr val="9A9A97"/>
-                </a:solidFill>
-                <a:latin typeface="Arial" pitchFamily="34" charset="0"/>
-                <a:ea typeface="Arial" pitchFamily="34" charset="-122"/>
-                <a:cs typeface="Arial" pitchFamily="34" charset="-120"/>
-              </a:rPr>
-              <a:t>Presented by </a:t>
-            </a:r>
-            <a:r>
-              <a:rPr lang="en-US" sz="1500" b="1" dirty="0">
-                <a:solidFill>
-                  <a:srgbClr val="FFFFFF"/>
-                </a:solidFill>
-                <a:latin typeface="Arial" pitchFamily="34" charset="0"/>
-                <a:ea typeface="Arial" pitchFamily="34" charset="-122"/>
-                <a:cs typeface="Arial" pitchFamily="34" charset="-120"/>
-              </a:rPr>
-              <a:t>Yasin &amp; Mevlüt</a:t>
-            </a:r>
-            <a:endParaRPr lang="en-US" sz="1500" dirty="0"/>
           </a:p>
         </p:txBody>
       </p:sp>
@@ -16408,45 +16526,6 @@
       </p:sp>
       <p:sp>
         <p:nvSpPr>
-          <p:cNvPr id="6" name="Text 4"/>
-          <p:cNvSpPr/>
-          <p:nvPr/>
-        </p:nvSpPr>
-        <p:spPr>
-          <a:xfrm>
-            <a:off x="640080" y="6437376"/>
-            <a:ext cx="8229600" cy="274320"/>
-          </a:xfrm>
-          <a:prstGeom prst="rect">
-            <a:avLst/>
-          </a:prstGeom>
-          <a:noFill/>
-          <a:ln/>
-        </p:spPr>
-        <p:txBody>
-          <a:bodyPr wrap="square" lIns="0" tIns="0" rIns="0" bIns="0" rtlCol="0" anchor="ctr"/>
-          <a:lstStyle/>
-          <a:p>
-            <a:pPr marL="0" indent="0">
-              <a:buNone/>
-            </a:pPr>
-            <a:r>
-              <a:rPr lang="en-US" sz="900" dirty="0">
-                <a:solidFill>
-                  <a:srgbClr val="6E6E6C"/>
-                </a:solidFill>
-                <a:latin typeface="Arial" pitchFamily="34" charset="0"/>
-                <a:ea typeface="Arial" pitchFamily="34" charset="-122"/>
-                <a:cs typeface="Arial" pitchFamily="34" charset="-120"/>
-              </a:rPr>
-              <a:t>HTWG Konstanz  ·  System Architecture  ·  Group E</a:t>
-            </a:r>
-            <a:endParaRPr lang="en-US" sz="900" dirty="0"/>
-          </a:p>
-        </p:txBody>
-      </p:sp>
-      <p:sp>
-        <p:nvSpPr>
           <p:cNvPr id="7" name="Text 5"/>
           <p:cNvSpPr/>
           <p:nvPr/>
@@ -17391,45 +17470,6 @@
       </p:sp>
       <p:sp>
         <p:nvSpPr>
-          <p:cNvPr id="6" name="Text 4"/>
-          <p:cNvSpPr/>
-          <p:nvPr/>
-        </p:nvSpPr>
-        <p:spPr>
-          <a:xfrm>
-            <a:off x="640080" y="6437376"/>
-            <a:ext cx="8229600" cy="274320"/>
-          </a:xfrm>
-          <a:prstGeom prst="rect">
-            <a:avLst/>
-          </a:prstGeom>
-          <a:noFill/>
-          <a:ln/>
-        </p:spPr>
-        <p:txBody>
-          <a:bodyPr wrap="square" lIns="0" tIns="0" rIns="0" bIns="0" rtlCol="0" anchor="ctr"/>
-          <a:lstStyle/>
-          <a:p>
-            <a:pPr marL="0" indent="0">
-              <a:buNone/>
-            </a:pPr>
-            <a:r>
-              <a:rPr lang="en-US" sz="900" dirty="0">
-                <a:solidFill>
-                  <a:srgbClr val="6E6E6C"/>
-                </a:solidFill>
-                <a:latin typeface="Arial" pitchFamily="34" charset="0"/>
-                <a:ea typeface="Arial" pitchFamily="34" charset="-122"/>
-                <a:cs typeface="Arial" pitchFamily="34" charset="-120"/>
-              </a:rPr>
-              <a:t>HTWG Konstanz  ·  System Architecture  ·  Group E</a:t>
-            </a:r>
-            <a:endParaRPr lang="en-US" sz="900" dirty="0"/>
-          </a:p>
-        </p:txBody>
-      </p:sp>
-      <p:sp>
-        <p:nvSpPr>
           <p:cNvPr id="7" name="Text 5"/>
           <p:cNvSpPr/>
           <p:nvPr/>
@@ -17524,7 +17564,7 @@
               <a:buNone/>
             </a:pPr>
             <a:r>
-              <a:rPr lang="en-US" sz="1500" b="1" dirty="0">
+              <a:rPr lang="en-US" sz="1500" b="1" dirty="0" err="1">
                 <a:solidFill>
                   <a:srgbClr val="2D2D2B"/>
                 </a:solidFill>
@@ -17532,7 +17572,7 @@
                 <a:ea typeface="Arial" pitchFamily="34" charset="-122"/>
                 <a:cs typeface="Arial" pitchFamily="34" charset="-120"/>
               </a:rPr>
-              <a:t>SysArch_HMI (us)</a:t>
+              <a:t>SysArch_HMI</a:t>
             </a:r>
             <a:endParaRPr lang="en-US" sz="1500" dirty="0"/>
           </a:p>
@@ -18336,45 +18376,6 @@
           <a:lstStyle/>
           <a:p>
             <a:endParaRPr lang="de-DE"/>
-          </a:p>
-        </p:txBody>
-      </p:sp>
-      <p:sp>
-        <p:nvSpPr>
-          <p:cNvPr id="6" name="Text 4"/>
-          <p:cNvSpPr/>
-          <p:nvPr/>
-        </p:nvSpPr>
-        <p:spPr>
-          <a:xfrm>
-            <a:off x="640080" y="6437376"/>
-            <a:ext cx="8229600" cy="274320"/>
-          </a:xfrm>
-          <a:prstGeom prst="rect">
-            <a:avLst/>
-          </a:prstGeom>
-          <a:noFill/>
-          <a:ln/>
-        </p:spPr>
-        <p:txBody>
-          <a:bodyPr wrap="square" lIns="0" tIns="0" rIns="0" bIns="0" rtlCol="0" anchor="ctr"/>
-          <a:lstStyle/>
-          <a:p>
-            <a:pPr marL="0" indent="0">
-              <a:buNone/>
-            </a:pPr>
-            <a:r>
-              <a:rPr lang="en-US" sz="900" dirty="0">
-                <a:solidFill>
-                  <a:srgbClr val="6E6E6C"/>
-                </a:solidFill>
-                <a:latin typeface="Arial" pitchFamily="34" charset="0"/>
-                <a:ea typeface="Arial" pitchFamily="34" charset="-122"/>
-                <a:cs typeface="Arial" pitchFamily="34" charset="-120"/>
-              </a:rPr>
-              <a:t>HTWG Konstanz  ·  System Architecture  ·  Group E</a:t>
-            </a:r>
-            <a:endParaRPr lang="en-US" sz="900" dirty="0"/>
           </a:p>
         </p:txBody>
       </p:sp>
@@ -20051,45 +20052,6 @@
       </p:sp>
       <p:sp>
         <p:nvSpPr>
-          <p:cNvPr id="6" name="Text 4"/>
-          <p:cNvSpPr/>
-          <p:nvPr/>
-        </p:nvSpPr>
-        <p:spPr>
-          <a:xfrm>
-            <a:off x="640080" y="6437376"/>
-            <a:ext cx="8229600" cy="274320"/>
-          </a:xfrm>
-          <a:prstGeom prst="rect">
-            <a:avLst/>
-          </a:prstGeom>
-          <a:noFill/>
-          <a:ln/>
-        </p:spPr>
-        <p:txBody>
-          <a:bodyPr wrap="square" lIns="0" tIns="0" rIns="0" bIns="0" rtlCol="0" anchor="ctr"/>
-          <a:lstStyle/>
-          <a:p>
-            <a:pPr marL="0" indent="0">
-              <a:buNone/>
-            </a:pPr>
-            <a:r>
-              <a:rPr lang="en-US" sz="900" dirty="0">
-                <a:solidFill>
-                  <a:srgbClr val="6E6E6C"/>
-                </a:solidFill>
-                <a:latin typeface="Arial" pitchFamily="34" charset="0"/>
-                <a:ea typeface="Arial" pitchFamily="34" charset="-122"/>
-                <a:cs typeface="Arial" pitchFamily="34" charset="-120"/>
-              </a:rPr>
-              <a:t>HTWG Konstanz  ·  System Architecture  ·  Group E</a:t>
-            </a:r>
-            <a:endParaRPr lang="en-US" sz="900" dirty="0"/>
-          </a:p>
-        </p:txBody>
-      </p:sp>
-      <p:sp>
-        <p:nvSpPr>
           <p:cNvPr id="7" name="Text 5"/>
           <p:cNvSpPr/>
           <p:nvPr/>
@@ -22536,45 +22498,6 @@
           </a:graphicData>
         </a:graphic>
       </p:graphicFrame>
-      <p:sp>
-        <p:nvSpPr>
-          <p:cNvPr id="11" name="Text 7"/>
-          <p:cNvSpPr/>
-          <p:nvPr/>
-        </p:nvSpPr>
-        <p:spPr>
-          <a:xfrm>
-            <a:off x="640080" y="6163056"/>
-            <a:ext cx="10972800" cy="274320"/>
-          </a:xfrm>
-          <a:prstGeom prst="rect">
-            <a:avLst/>
-          </a:prstGeom>
-          <a:noFill/>
-          <a:ln/>
-        </p:spPr>
-        <p:txBody>
-          <a:bodyPr wrap="square" lIns="0" tIns="0" rIns="0" bIns="0" rtlCol="0" anchor="ctr"/>
-          <a:lstStyle/>
-          <a:p>
-            <a:pPr marL="0" indent="0">
-              <a:buNone/>
-            </a:pPr>
-            <a:r>
-              <a:rPr lang="en-US" sz="1100" i="1" dirty="0">
-                <a:solidFill>
-                  <a:srgbClr val="6E6E6C"/>
-                </a:solidFill>
-                <a:latin typeface="Arial" pitchFamily="34" charset="0"/>
-                <a:ea typeface="Arial" pitchFamily="34" charset="-122"/>
-                <a:cs typeface="Arial" pitchFamily="34" charset="-120"/>
-              </a:rPr>
-              <a:t>Field names are the JSON keys; they are identical on both sides of the MQTT contract.</a:t>
-            </a:r>
-            <a:endParaRPr lang="en-US" sz="1100" dirty="0"/>
-          </a:p>
-        </p:txBody>
-      </p:sp>
     </p:spTree>
   </p:cSld>
   <p:clrMapOvr>
@@ -22718,45 +22641,6 @@
       </p:sp>
       <p:sp>
         <p:nvSpPr>
-          <p:cNvPr id="6" name="Text 4"/>
-          <p:cNvSpPr/>
-          <p:nvPr/>
-        </p:nvSpPr>
-        <p:spPr>
-          <a:xfrm>
-            <a:off x="640080" y="6437376"/>
-            <a:ext cx="8229600" cy="274320"/>
-          </a:xfrm>
-          <a:prstGeom prst="rect">
-            <a:avLst/>
-          </a:prstGeom>
-          <a:noFill/>
-          <a:ln/>
-        </p:spPr>
-        <p:txBody>
-          <a:bodyPr wrap="square" lIns="0" tIns="0" rIns="0" bIns="0" rtlCol="0" anchor="ctr"/>
-          <a:lstStyle/>
-          <a:p>
-            <a:pPr marL="0" indent="0">
-              <a:buNone/>
-            </a:pPr>
-            <a:r>
-              <a:rPr lang="en-US" sz="900" dirty="0">
-                <a:solidFill>
-                  <a:srgbClr val="6E6E6C"/>
-                </a:solidFill>
-                <a:latin typeface="Arial" pitchFamily="34" charset="0"/>
-                <a:ea typeface="Arial" pitchFamily="34" charset="-122"/>
-                <a:cs typeface="Arial" pitchFamily="34" charset="-120"/>
-              </a:rPr>
-              <a:t>HTWG Konstanz  ·  System Architecture  ·  Group E</a:t>
-            </a:r>
-            <a:endParaRPr lang="en-US" sz="900" dirty="0"/>
-          </a:p>
-        </p:txBody>
-      </p:sp>
-      <p:sp>
-        <p:nvSpPr>
           <p:cNvPr id="7" name="Text 5"/>
           <p:cNvSpPr/>
           <p:nvPr/>
@@ -23492,7 +23376,7 @@
         </p:nvSpPr>
         <p:spPr>
           <a:xfrm>
-            <a:off x="841248" y="3703320"/>
+            <a:off x="868680" y="3269411"/>
             <a:ext cx="9875520" cy="822960"/>
           </a:xfrm>
           <a:prstGeom prst="rect">
@@ -23520,56 +23404,6 @@
               <a:t>Requirements, hexagonal architecture, the SCAN logic, I/O, deployment and a live demo.</a:t>
             </a:r>
             <a:endParaRPr lang="en-US" sz="1700" dirty="0"/>
-          </a:p>
-        </p:txBody>
-      </p:sp>
-      <p:sp>
-        <p:nvSpPr>
-          <p:cNvPr id="6" name="Text 4"/>
-          <p:cNvSpPr/>
-          <p:nvPr/>
-        </p:nvSpPr>
-        <p:spPr>
-          <a:xfrm>
-            <a:off x="841248" y="4800600"/>
-            <a:ext cx="8229600" cy="365760"/>
-          </a:xfrm>
-          <a:prstGeom prst="rect">
-            <a:avLst/>
-          </a:prstGeom>
-          <a:noFill/>
-          <a:ln/>
-        </p:spPr>
-        <p:txBody>
-          <a:bodyPr wrap="square" lIns="0" tIns="0" rIns="0" bIns="0" rtlCol="0" anchor="ctr"/>
-          <a:lstStyle/>
-          <a:p>
-            <a:pPr marL="0" indent="0">
-              <a:buNone/>
-            </a:pPr>
-            <a:r>
-              <a:rPr lang="en-US" sz="1500" dirty="0">
-                <a:solidFill>
-                  <a:srgbClr val="9A9A97"/>
-                </a:solidFill>
-                <a:latin typeface="Arial" pitchFamily="34" charset="0"/>
-                <a:ea typeface="Arial" pitchFamily="34" charset="-122"/>
-                <a:cs typeface="Arial" pitchFamily="34" charset="-120"/>
-              </a:rPr>
-              <a:t>Presented by </a:t>
-            </a:r>
-            <a:r>
-              <a:rPr lang="en-US" sz="1500" b="1" dirty="0">
-                <a:solidFill>
-                  <a:srgbClr val="FFFFFF"/>
-                </a:solidFill>
-                <a:latin typeface="Arial" pitchFamily="34" charset="0"/>
-                <a:ea typeface="Arial" pitchFamily="34" charset="-122"/>
-                <a:cs typeface="Arial" pitchFamily="34" charset="-120"/>
-              </a:rPr>
-              <a:t>Ruben &amp; Lukas</a:t>
-            </a:r>
-            <a:endParaRPr lang="en-US" sz="1500" dirty="0"/>
           </a:p>
         </p:txBody>
       </p:sp>

</xml_diff>